<commit_message>
Add docs reverse-proxy, harden compose healthchecks, fix workflow backup/restore
- Add docs service + nginx /docs routes across dev/prod/prod-main
- Redis: internal-only port with AOF persistence instead of exposed 6379
- Postgres: restart policy + healthcheck; n8n/admin-api wait on
  service_healthy instead of service_started
- Restore fastapi's writable .git mount on prod + prod-worker (was
  silently breaking the n8n "Git commit all workflow files" workflow)
- Parameterize project ID in workflow data-table backup/restore so
  backups aren't tied to the source instance's project ID; strip
  \restrict/\unrestrict for newer pg_dump compatibility
- Add remove_bad_video_files.sh to prune corrupt video files
</commit_message>
<xml_diff>
--- a/assets/job_news_template.pptx
+++ b/assets/job_news_template.pptx
@@ -10,7 +10,7 @@
   <p:sldIdLst>
     <p:sldId id="256" r:id="rId8"/>
   </p:sldIdLst>
-  <p:sldSz cx="8229600" cy="14630400"/>
+  <p:sldSz cx="12192000" cy="6858000"/>
   <p:notesSz cx="6858000" cy="9144000"/>
   <p:defaultTextStyle>
     <a:defPPr marL="0" marR="0" indent="0" algn="l" defTabSz="914400" rtl="0" fontAlgn="auto" latinLnBrk="1" hangingPunct="0">
@@ -54,7 +54,7 @@
       <a:buFontTx/>
       <a:buNone/>
       <a:tabLst/>
-      <a:defRPr b="0" baseline="0" cap="none" i="0" spc="0" strike="noStrike" sz="1400" u="none" kumimoji="0" normalizeH="0">
+      <a:defRPr b="0" baseline="0" cap="none" i="0" spc="0" strike="noStrike" sz="1800" u="none" kumimoji="0" normalizeH="0">
         <a:ln>
           <a:noFill/>
         </a:ln>
@@ -66,7 +66,7 @@
         <a:latin typeface="+mn-lt"/>
         <a:ea typeface="+mn-ea"/>
         <a:cs typeface="+mn-cs"/>
-        <a:sym typeface="Arial"/>
+        <a:sym typeface="Helvetica"/>
       </a:defRPr>
     </a:lvl1pPr>
     <a:lvl2pPr marL="0" marR="0" indent="0" algn="l" defTabSz="914400" rtl="0" fontAlgn="auto" latinLnBrk="0" hangingPunct="0">
@@ -84,7 +84,7 @@
       <a:buFontTx/>
       <a:buNone/>
       <a:tabLst/>
-      <a:defRPr b="0" baseline="0" cap="none" i="0" spc="0" strike="noStrike" sz="1400" u="none" kumimoji="0" normalizeH="0">
+      <a:defRPr b="0" baseline="0" cap="none" i="0" spc="0" strike="noStrike" sz="1800" u="none" kumimoji="0" normalizeH="0">
         <a:ln>
           <a:noFill/>
         </a:ln>
@@ -96,7 +96,7 @@
         <a:latin typeface="+mn-lt"/>
         <a:ea typeface="+mn-ea"/>
         <a:cs typeface="+mn-cs"/>
-        <a:sym typeface="Arial"/>
+        <a:sym typeface="Helvetica"/>
       </a:defRPr>
     </a:lvl2pPr>
     <a:lvl3pPr marL="0" marR="0" indent="0" algn="l" defTabSz="914400" rtl="0" fontAlgn="auto" latinLnBrk="0" hangingPunct="0">
@@ -114,7 +114,7 @@
       <a:buFontTx/>
       <a:buNone/>
       <a:tabLst/>
-      <a:defRPr b="0" baseline="0" cap="none" i="0" spc="0" strike="noStrike" sz="1400" u="none" kumimoji="0" normalizeH="0">
+      <a:defRPr b="0" baseline="0" cap="none" i="0" spc="0" strike="noStrike" sz="1800" u="none" kumimoji="0" normalizeH="0">
         <a:ln>
           <a:noFill/>
         </a:ln>
@@ -126,7 +126,7 @@
         <a:latin typeface="+mn-lt"/>
         <a:ea typeface="+mn-ea"/>
         <a:cs typeface="+mn-cs"/>
-        <a:sym typeface="Arial"/>
+        <a:sym typeface="Helvetica"/>
       </a:defRPr>
     </a:lvl3pPr>
     <a:lvl4pPr marL="0" marR="0" indent="0" algn="l" defTabSz="914400" rtl="0" fontAlgn="auto" latinLnBrk="0" hangingPunct="0">
@@ -144,7 +144,7 @@
       <a:buFontTx/>
       <a:buNone/>
       <a:tabLst/>
-      <a:defRPr b="0" baseline="0" cap="none" i="0" spc="0" strike="noStrike" sz="1400" u="none" kumimoji="0" normalizeH="0">
+      <a:defRPr b="0" baseline="0" cap="none" i="0" spc="0" strike="noStrike" sz="1800" u="none" kumimoji="0" normalizeH="0">
         <a:ln>
           <a:noFill/>
         </a:ln>
@@ -156,7 +156,7 @@
         <a:latin typeface="+mn-lt"/>
         <a:ea typeface="+mn-ea"/>
         <a:cs typeface="+mn-cs"/>
-        <a:sym typeface="Arial"/>
+        <a:sym typeface="Helvetica"/>
       </a:defRPr>
     </a:lvl4pPr>
     <a:lvl5pPr marL="0" marR="0" indent="0" algn="l" defTabSz="914400" rtl="0" fontAlgn="auto" latinLnBrk="0" hangingPunct="0">
@@ -174,7 +174,7 @@
       <a:buFontTx/>
       <a:buNone/>
       <a:tabLst/>
-      <a:defRPr b="0" baseline="0" cap="none" i="0" spc="0" strike="noStrike" sz="1400" u="none" kumimoji="0" normalizeH="0">
+      <a:defRPr b="0" baseline="0" cap="none" i="0" spc="0" strike="noStrike" sz="1800" u="none" kumimoji="0" normalizeH="0">
         <a:ln>
           <a:noFill/>
         </a:ln>
@@ -186,7 +186,7 @@
         <a:latin typeface="+mn-lt"/>
         <a:ea typeface="+mn-ea"/>
         <a:cs typeface="+mn-cs"/>
-        <a:sym typeface="Arial"/>
+        <a:sym typeface="Helvetica"/>
       </a:defRPr>
     </a:lvl5pPr>
     <a:lvl6pPr marL="0" marR="0" indent="0" algn="l" defTabSz="914400" rtl="0" fontAlgn="auto" latinLnBrk="0" hangingPunct="0">
@@ -204,7 +204,7 @@
       <a:buFontTx/>
       <a:buNone/>
       <a:tabLst/>
-      <a:defRPr b="0" baseline="0" cap="none" i="0" spc="0" strike="noStrike" sz="1400" u="none" kumimoji="0" normalizeH="0">
+      <a:defRPr b="0" baseline="0" cap="none" i="0" spc="0" strike="noStrike" sz="1800" u="none" kumimoji="0" normalizeH="0">
         <a:ln>
           <a:noFill/>
         </a:ln>
@@ -216,7 +216,7 @@
         <a:latin typeface="+mn-lt"/>
         <a:ea typeface="+mn-ea"/>
         <a:cs typeface="+mn-cs"/>
-        <a:sym typeface="Arial"/>
+        <a:sym typeface="Helvetica"/>
       </a:defRPr>
     </a:lvl6pPr>
     <a:lvl7pPr marL="0" marR="0" indent="0" algn="l" defTabSz="914400" rtl="0" fontAlgn="auto" latinLnBrk="0" hangingPunct="0">
@@ -234,7 +234,7 @@
       <a:buFontTx/>
       <a:buNone/>
       <a:tabLst/>
-      <a:defRPr b="0" baseline="0" cap="none" i="0" spc="0" strike="noStrike" sz="1400" u="none" kumimoji="0" normalizeH="0">
+      <a:defRPr b="0" baseline="0" cap="none" i="0" spc="0" strike="noStrike" sz="1800" u="none" kumimoji="0" normalizeH="0">
         <a:ln>
           <a:noFill/>
         </a:ln>
@@ -246,7 +246,7 @@
         <a:latin typeface="+mn-lt"/>
         <a:ea typeface="+mn-ea"/>
         <a:cs typeface="+mn-cs"/>
-        <a:sym typeface="Arial"/>
+        <a:sym typeface="Helvetica"/>
       </a:defRPr>
     </a:lvl7pPr>
     <a:lvl8pPr marL="0" marR="0" indent="0" algn="l" defTabSz="914400" rtl="0" fontAlgn="auto" latinLnBrk="0" hangingPunct="0">
@@ -264,7 +264,7 @@
       <a:buFontTx/>
       <a:buNone/>
       <a:tabLst/>
-      <a:defRPr b="0" baseline="0" cap="none" i="0" spc="0" strike="noStrike" sz="1400" u="none" kumimoji="0" normalizeH="0">
+      <a:defRPr b="0" baseline="0" cap="none" i="0" spc="0" strike="noStrike" sz="1800" u="none" kumimoji="0" normalizeH="0">
         <a:ln>
           <a:noFill/>
         </a:ln>
@@ -276,7 +276,7 @@
         <a:latin typeface="+mn-lt"/>
         <a:ea typeface="+mn-ea"/>
         <a:cs typeface="+mn-cs"/>
-        <a:sym typeface="Arial"/>
+        <a:sym typeface="Helvetica"/>
       </a:defRPr>
     </a:lvl8pPr>
     <a:lvl9pPr marL="0" marR="0" indent="0" algn="l" defTabSz="914400" rtl="0" fontAlgn="auto" latinLnBrk="0" hangingPunct="0">
@@ -294,7 +294,7 @@
       <a:buFontTx/>
       <a:buNone/>
       <a:tabLst/>
-      <a:defRPr b="0" baseline="0" cap="none" i="0" spc="0" strike="noStrike" sz="1400" u="none" kumimoji="0" normalizeH="0">
+      <a:defRPr b="0" baseline="0" cap="none" i="0" spc="0" strike="noStrike" sz="1800" u="none" kumimoji="0" normalizeH="0">
         <a:ln>
           <a:noFill/>
         </a:ln>
@@ -306,7 +306,7 @@
         <a:latin typeface="+mn-lt"/>
         <a:ea typeface="+mn-ea"/>
         <a:cs typeface="+mn-cs"/>
-        <a:sym typeface="Arial"/>
+        <a:sym typeface="Helvetica"/>
       </a:defRPr>
     </a:lvl9pPr>
   </p:defaultTextStyle>
@@ -336,7 +336,7 @@
       </p:grpSpPr>
       <p:sp>
         <p:nvSpPr>
-          <p:cNvPr id="108" name="Shape 108"/>
+          <p:cNvPr id="101" name="Shape 101"/>
           <p:cNvSpPr/>
           <p:nvPr>
             <p:ph type="sldImg"/>
@@ -361,7 +361,7 @@
       </p:sp>
       <p:sp>
         <p:nvSpPr>
-          <p:cNvPr id="109" name="Shape 109"/>
+          <p:cNvPr id="102" name="Shape 102"/>
           <p:cNvSpPr/>
           <p:nvPr>
             <p:ph type="body" sz="quarter" idx="1"/>
@@ -389,75 +389,75 @@
   <p:clrMap bg1="lt1" tx1="dk1" bg2="lt2" tx2="dk2" accent1="accent1" accent2="accent2" accent3="accent3" accent4="accent4" accent5="accent5" accent6="accent6" hlink="hlink" folHlink="folHlink"/>
   <p:notesStyle>
     <a:lvl1pPr latinLnBrk="0">
-      <a:defRPr sz="1400">
-        <a:latin typeface="+mn-lt"/>
-        <a:ea typeface="+mn-ea"/>
-        <a:cs typeface="+mn-cs"/>
-        <a:sym typeface="Arial"/>
+      <a:defRPr sz="1200">
+        <a:latin typeface="+mj-lt"/>
+        <a:ea typeface="+mj-ea"/>
+        <a:cs typeface="+mj-cs"/>
+        <a:sym typeface="Aptos"/>
       </a:defRPr>
     </a:lvl1pPr>
     <a:lvl2pPr indent="228600" latinLnBrk="0">
-      <a:defRPr sz="1400">
-        <a:latin typeface="+mn-lt"/>
-        <a:ea typeface="+mn-ea"/>
-        <a:cs typeface="+mn-cs"/>
-        <a:sym typeface="Arial"/>
+      <a:defRPr sz="1200">
+        <a:latin typeface="+mj-lt"/>
+        <a:ea typeface="+mj-ea"/>
+        <a:cs typeface="+mj-cs"/>
+        <a:sym typeface="Aptos"/>
       </a:defRPr>
     </a:lvl2pPr>
     <a:lvl3pPr indent="457200" latinLnBrk="0">
-      <a:defRPr sz="1400">
-        <a:latin typeface="+mn-lt"/>
-        <a:ea typeface="+mn-ea"/>
-        <a:cs typeface="+mn-cs"/>
-        <a:sym typeface="Arial"/>
+      <a:defRPr sz="1200">
+        <a:latin typeface="+mj-lt"/>
+        <a:ea typeface="+mj-ea"/>
+        <a:cs typeface="+mj-cs"/>
+        <a:sym typeface="Aptos"/>
       </a:defRPr>
     </a:lvl3pPr>
     <a:lvl4pPr indent="685800" latinLnBrk="0">
-      <a:defRPr sz="1400">
-        <a:latin typeface="+mn-lt"/>
-        <a:ea typeface="+mn-ea"/>
-        <a:cs typeface="+mn-cs"/>
-        <a:sym typeface="Arial"/>
+      <a:defRPr sz="1200">
+        <a:latin typeface="+mj-lt"/>
+        <a:ea typeface="+mj-ea"/>
+        <a:cs typeface="+mj-cs"/>
+        <a:sym typeface="Aptos"/>
       </a:defRPr>
     </a:lvl4pPr>
     <a:lvl5pPr indent="914400" latinLnBrk="0">
-      <a:defRPr sz="1400">
-        <a:latin typeface="+mn-lt"/>
-        <a:ea typeface="+mn-ea"/>
-        <a:cs typeface="+mn-cs"/>
-        <a:sym typeface="Arial"/>
+      <a:defRPr sz="1200">
+        <a:latin typeface="+mj-lt"/>
+        <a:ea typeface="+mj-ea"/>
+        <a:cs typeface="+mj-cs"/>
+        <a:sym typeface="Aptos"/>
       </a:defRPr>
     </a:lvl5pPr>
     <a:lvl6pPr indent="1143000" latinLnBrk="0">
-      <a:defRPr sz="1400">
-        <a:latin typeface="+mn-lt"/>
-        <a:ea typeface="+mn-ea"/>
-        <a:cs typeface="+mn-cs"/>
-        <a:sym typeface="Arial"/>
+      <a:defRPr sz="1200">
+        <a:latin typeface="+mj-lt"/>
+        <a:ea typeface="+mj-ea"/>
+        <a:cs typeface="+mj-cs"/>
+        <a:sym typeface="Aptos"/>
       </a:defRPr>
     </a:lvl6pPr>
     <a:lvl7pPr indent="1371600" latinLnBrk="0">
-      <a:defRPr sz="1400">
-        <a:latin typeface="+mn-lt"/>
-        <a:ea typeface="+mn-ea"/>
-        <a:cs typeface="+mn-cs"/>
-        <a:sym typeface="Arial"/>
+      <a:defRPr sz="1200">
+        <a:latin typeface="+mj-lt"/>
+        <a:ea typeface="+mj-ea"/>
+        <a:cs typeface="+mj-cs"/>
+        <a:sym typeface="Aptos"/>
       </a:defRPr>
     </a:lvl7pPr>
     <a:lvl8pPr indent="1600200" latinLnBrk="0">
-      <a:defRPr sz="1400">
-        <a:latin typeface="+mn-lt"/>
-        <a:ea typeface="+mn-ea"/>
-        <a:cs typeface="+mn-cs"/>
-        <a:sym typeface="Arial"/>
+      <a:defRPr sz="1200">
+        <a:latin typeface="+mj-lt"/>
+        <a:ea typeface="+mj-ea"/>
+        <a:cs typeface="+mj-cs"/>
+        <a:sym typeface="Aptos"/>
       </a:defRPr>
     </a:lvl8pPr>
     <a:lvl9pPr indent="1828800" latinLnBrk="0">
-      <a:defRPr sz="1400">
-        <a:latin typeface="+mn-lt"/>
-        <a:ea typeface="+mn-ea"/>
-        <a:cs typeface="+mn-cs"/>
-        <a:sym typeface="Arial"/>
+      <a:defRPr sz="1200">
+        <a:latin typeface="+mj-lt"/>
+        <a:ea typeface="+mj-ea"/>
+        <a:cs typeface="+mj-cs"/>
+        <a:sym typeface="Aptos"/>
       </a:defRPr>
     </a:lvl9pPr>
   </p:notesStyle>
@@ -465,8 +465,171 @@
 </file>
 
 <file path=ppt/slideLayouts/slideLayout1.xml><?xml version="1.0" encoding="utf-8"?>
-<p:sldLayout xmlns:a="http://schemas.openxmlformats.org/drawingml/2006/main" xmlns:r="http://schemas.openxmlformats.org/officeDocument/2006/relationships" xmlns:p="http://schemas.openxmlformats.org/presentationml/2006/main" xmlns:m="http://schemas.openxmlformats.org/officeDocument/2006/math" xmlns:a14="http://schemas.microsoft.com/office/drawing/2010/main" type="title" showMasterSp="1" showMasterPhAnim="1">
-  <p:cSld name="TITLE">
+<p:sldLayout xmlns:a="http://schemas.openxmlformats.org/drawingml/2006/main" xmlns:r="http://schemas.openxmlformats.org/officeDocument/2006/relationships" xmlns:p="http://schemas.openxmlformats.org/presentationml/2006/main" xmlns:m="http://schemas.openxmlformats.org/officeDocument/2006/math" xmlns:a14="http://schemas.microsoft.com/office/drawing/2010/main" type="tx" showMasterSp="1" showMasterPhAnim="1">
+  <p:cSld name="JNN Layout">
+    <p:spTree>
+      <p:nvGrpSpPr>
+        <p:cNvPr id="1" name=""/>
+        <p:cNvGrpSpPr/>
+        <p:nvPr/>
+      </p:nvGrpSpPr>
+      <p:grpSpPr>
+        <a:xfrm>
+          <a:off x="0" y="0"/>
+          <a:ext cx="0" cy="0"/>
+          <a:chOff x="0" y="0"/>
+          <a:chExt cx="0" cy="0"/>
+        </a:xfrm>
+      </p:grpSpPr>
+      <p:pic>
+        <p:nvPicPr>
+          <p:cNvPr id="11" name="Picture 10" descr="Picture 10"/>
+          <p:cNvPicPr>
+            <a:picLocks noChangeAspect="1"/>
+          </p:cNvPicPr>
+          <p:nvPr/>
+        </p:nvPicPr>
+        <p:blipFill>
+          <a:blip r:embed="rId2">
+            <a:extLst/>
+          </a:blip>
+          <a:stretch>
+            <a:fillRect/>
+          </a:stretch>
+        </p:blipFill>
+        <p:spPr>
+          <a:xfrm>
+            <a:off x="9937812" y="105518"/>
+            <a:ext cx="2133601" cy="889004"/>
+          </a:xfrm>
+          <a:prstGeom prst="rect">
+            <a:avLst/>
+          </a:prstGeom>
+          <a:ln w="12700">
+            <a:miter lim="400000"/>
+          </a:ln>
+        </p:spPr>
+      </p:pic>
+      <p:sp>
+        <p:nvSpPr>
+          <p:cNvPr id="12" name="TextBox 11"/>
+          <p:cNvSpPr txBox="1"/>
+          <p:nvPr/>
+        </p:nvSpPr>
+        <p:spPr>
+          <a:xfrm>
+            <a:off x="274315" y="135999"/>
+            <a:ext cx="9509770" cy="828037"/>
+          </a:xfrm>
+          <a:prstGeom prst="rect">
+            <a:avLst/>
+          </a:prstGeom>
+          <a:ln w="12700">
+            <a:miter lim="400000"/>
+          </a:ln>
+          <a:extLst>
+            <a:ext uri="{C572A759-6A51-4108-AA02-DFA0A04FC94B}">
+              <ma14:wrappingTextBoxFlag xmlns:ma14="http://schemas.microsoft.com/office/mac/drawingml/2011/main" val="1"/>
+            </a:ext>
+          </a:extLst>
+        </p:spPr>
+        <p:txBody>
+          <a:bodyPr lIns="45718" tIns="45718" rIns="45718" bIns="45718">
+            <a:spAutoFit/>
+          </a:bodyPr>
+          <a:lstStyle>
+            <a:lvl1pPr>
+              <a:defRPr b="1" i="1" sz="4800">
+                <a:ln w="25400" cap="flat">
+                  <a:solidFill>
+                    <a:srgbClr val="092937"/>
+                  </a:solidFill>
+                  <a:prstDash val="solid"/>
+                  <a:round/>
+                </a:ln>
+                <a:solidFill>
+                  <a:srgbClr val="FFFFFF"/>
+                </a:solidFill>
+                <a:latin typeface="Lexia Black"/>
+                <a:ea typeface="Lexia Black"/>
+                <a:cs typeface="Lexia Black"/>
+                <a:sym typeface="Lexia Black"/>
+              </a:defRPr>
+            </a:lvl1pPr>
+          </a:lstStyle>
+          <a:p>
+            <a:pPr/>
+            <a:r>
+              <a:t>JNN - JOB NEWS NETWORK</a:t>
+            </a:r>
+          </a:p>
+        </p:txBody>
+      </p:sp>
+      <p:sp>
+        <p:nvSpPr>
+          <p:cNvPr id="13" name="Picture Placeholder 6"/>
+          <p:cNvSpPr/>
+          <p:nvPr>
+            <p:ph type="pic" idx="21"/>
+          </p:nvPr>
+        </p:nvSpPr>
+        <p:spPr>
+          <a:xfrm>
+            <a:off x="287856" y="1080207"/>
+            <a:ext cx="11616287" cy="5546109"/>
+          </a:xfrm>
+          <a:prstGeom prst="rect">
+            <a:avLst/>
+          </a:prstGeom>
+        </p:spPr>
+        <p:txBody>
+          <a:bodyPr lIns="91439" tIns="45719" rIns="91439" bIns="45719">
+            <a:noAutofit/>
+          </a:bodyPr>
+          <a:lstStyle/>
+          <a:p>
+            <a:pPr/>
+          </a:p>
+        </p:txBody>
+      </p:sp>
+      <p:sp>
+        <p:nvSpPr>
+          <p:cNvPr id="14" name="Slide Number"/>
+          <p:cNvSpPr txBox="1"/>
+          <p:nvPr>
+            <p:ph type="sldNum" sz="quarter" idx="2"/>
+          </p:nvPr>
+        </p:nvSpPr>
+        <p:spPr>
+          <a:xfrm>
+            <a:off x="8463951" y="6221732"/>
+            <a:ext cx="273652" cy="269237"/>
+          </a:xfrm>
+          <a:prstGeom prst="rect">
+            <a:avLst/>
+          </a:prstGeom>
+        </p:spPr>
+        <p:txBody>
+          <a:bodyPr/>
+          <a:lstStyle/>
+          <a:p>
+            <a:pPr/>
+            <a:fld id="{86CB4B4D-7CA3-9044-876B-883B54F8677D}" type="slidenum"/>
+          </a:p>
+        </p:txBody>
+      </p:sp>
+    </p:spTree>
+  </p:cSld>
+  <p:clrMapOvr>
+    <a:masterClrMapping/>
+  </p:clrMapOvr>
+  <p:transition xmlns:p14="http://schemas.microsoft.com/office/powerpoint/2010/main" spd="med" advClick="1"/>
+</p:sldLayout>
+</file>
+
+<file path=ppt/slideLayouts/slideLayout10.xml><?xml version="1.0" encoding="utf-8"?>
+<p:sldLayout xmlns:a="http://schemas.openxmlformats.org/drawingml/2006/main" xmlns:r="http://schemas.openxmlformats.org/officeDocument/2006/relationships" xmlns:p="http://schemas.openxmlformats.org/presentationml/2006/main" xmlns:m="http://schemas.openxmlformats.org/officeDocument/2006/math" xmlns:a14="http://schemas.microsoft.com/office/drawing/2010/main" type="tx" showMasterSp="1" showMasterPhAnim="1">
+  <p:cSld name="Picture with Caption">
     <p:spTree>
       <p:nvGrpSpPr>
         <p:cNvPr id="1" name=""/>
@@ -483,79 +646,149 @@
       </p:grpSpPr>
       <p:sp>
         <p:nvSpPr>
-          <p:cNvPr id="11" name="Title Text"/>
+          <p:cNvPr id="92" name="Title Text"/>
           <p:cNvSpPr txBox="1"/>
           <p:nvPr>
             <p:ph type="title"/>
           </p:nvPr>
         </p:nvSpPr>
         <p:spPr>
+          <a:xfrm>
+            <a:off x="839787" y="457200"/>
+            <a:ext cx="3932240" cy="1600200"/>
+          </a:xfrm>
+          <a:prstGeom prst="rect">
+            <a:avLst/>
+          </a:prstGeom>
+        </p:spPr>
+        <p:txBody>
+          <a:bodyPr anchor="b"/>
+          <a:lstStyle>
+            <a:lvl1pPr>
+              <a:defRPr sz="3200"/>
+            </a:lvl1pPr>
+          </a:lstStyle>
+          <a:p>
+            <a:pPr/>
+            <a:r>
+              <a:t>Title Text</a:t>
+            </a:r>
+          </a:p>
+        </p:txBody>
+      </p:sp>
+      <p:sp>
+        <p:nvSpPr>
+          <p:cNvPr id="93" name="Picture Placeholder 2"/>
+          <p:cNvSpPr/>
+          <p:nvPr>
+            <p:ph type="pic" sz="half" idx="21"/>
+          </p:nvPr>
+        </p:nvSpPr>
+        <p:spPr>
+          <a:xfrm>
+            <a:off x="5183187" y="987425"/>
+            <a:ext cx="6172204" cy="4873625"/>
+          </a:xfrm>
+          <a:prstGeom prst="rect">
+            <a:avLst/>
+          </a:prstGeom>
+        </p:spPr>
+        <p:txBody>
+          <a:bodyPr lIns="91439" tIns="45719" rIns="91439" bIns="45719">
+            <a:noAutofit/>
+          </a:bodyPr>
+          <a:lstStyle/>
+          <a:p>
+            <a:pPr/>
+          </a:p>
+        </p:txBody>
+      </p:sp>
+      <p:sp>
+        <p:nvSpPr>
+          <p:cNvPr id="94" name="Body Level One…"/>
+          <p:cNvSpPr txBox="1"/>
+          <p:nvPr>
+            <p:ph type="body" sz="quarter" idx="1"/>
+          </p:nvPr>
+        </p:nvSpPr>
+        <p:spPr>
+          <a:xfrm>
+            <a:off x="839787" y="2057400"/>
+            <a:ext cx="3932240" cy="3811588"/>
+          </a:xfrm>
           <a:prstGeom prst="rect">
             <a:avLst/>
           </a:prstGeom>
         </p:spPr>
         <p:txBody>
           <a:bodyPr/>
-          <a:lstStyle/>
+          <a:lstStyle>
+            <a:lvl1pPr marL="0" indent="0">
+              <a:buSzTx/>
+              <a:buFontTx/>
+              <a:buNone/>
+              <a:defRPr sz="1600"/>
+            </a:lvl1pPr>
+            <a:lvl2pPr marL="0" indent="0">
+              <a:buSzTx/>
+              <a:buFontTx/>
+              <a:buNone/>
+              <a:defRPr sz="1600"/>
+            </a:lvl2pPr>
+            <a:lvl3pPr marL="0" indent="0">
+              <a:buSzTx/>
+              <a:buFontTx/>
+              <a:buNone/>
+              <a:defRPr sz="1600"/>
+            </a:lvl3pPr>
+            <a:lvl4pPr marL="0" indent="0">
+              <a:buSzTx/>
+              <a:buFontTx/>
+              <a:buNone/>
+              <a:defRPr sz="1600"/>
+            </a:lvl4pPr>
+            <a:lvl5pPr marL="0" indent="0">
+              <a:buSzTx/>
+              <a:buFontTx/>
+              <a:buNone/>
+              <a:defRPr sz="1600"/>
+            </a:lvl5pPr>
+          </a:lstStyle>
           <a:p>
             <a:pPr/>
             <a:r>
-              <a:t>Title Text</a:t>
+              <a:t>Body Level One</a:t>
+            </a:r>
+          </a:p>
+          <a:p>
+            <a:pPr lvl="1"/>
+            <a:r>
+              <a:t>Body Level Two</a:t>
+            </a:r>
+          </a:p>
+          <a:p>
+            <a:pPr lvl="2"/>
+            <a:r>
+              <a:t>Body Level Three</a:t>
+            </a:r>
+          </a:p>
+          <a:p>
+            <a:pPr lvl="3"/>
+            <a:r>
+              <a:t>Body Level Four</a:t>
+            </a:r>
+          </a:p>
+          <a:p>
+            <a:pPr lvl="4"/>
+            <a:r>
+              <a:t>Body Level Five</a:t>
             </a:r>
           </a:p>
         </p:txBody>
       </p:sp>
       <p:sp>
         <p:nvSpPr>
-          <p:cNvPr id="12" name="Body Level One…"/>
-          <p:cNvSpPr txBox="1"/>
-          <p:nvPr>
-            <p:ph type="body" sz="quarter" idx="1"/>
-          </p:nvPr>
-        </p:nvSpPr>
-        <p:spPr>
-          <a:prstGeom prst="rect">
-            <a:avLst/>
-          </a:prstGeom>
-        </p:spPr>
-        <p:txBody>
-          <a:bodyPr/>
-          <a:lstStyle/>
-          <a:p>
-            <a:pPr/>
-            <a:r>
-              <a:t>Body Level One</a:t>
-            </a:r>
-          </a:p>
-          <a:p>
-            <a:pPr lvl="1"/>
-            <a:r>
-              <a:t>Body Level Two</a:t>
-            </a:r>
-          </a:p>
-          <a:p>
-            <a:pPr lvl="2"/>
-            <a:r>
-              <a:t>Body Level Three</a:t>
-            </a:r>
-          </a:p>
-          <a:p>
-            <a:pPr lvl="3"/>
-            <a:r>
-              <a:t>Body Level Four</a:t>
-            </a:r>
-          </a:p>
-          <a:p>
-            <a:pPr lvl="4"/>
-            <a:r>
-              <a:t>Body Level Five</a:t>
-            </a:r>
-          </a:p>
-        </p:txBody>
-      </p:sp>
-      <p:sp>
-        <p:nvSpPr>
-          <p:cNvPr id="13" name="Slide Number"/>
+          <p:cNvPr id="95" name="Slide Number"/>
           <p:cNvSpPr txBox="1"/>
           <p:nvPr>
             <p:ph type="sldNum" sz="quarter" idx="2"/>
@@ -584,9 +817,9 @@
 </p:sldLayout>
 </file>
 
-<file path=ppt/slideLayouts/slideLayout10.xml><?xml version="1.0" encoding="utf-8"?>
+<file path=ppt/slideLayouts/slideLayout2.xml><?xml version="1.0" encoding="utf-8"?>
 <p:sldLayout xmlns:a="http://schemas.openxmlformats.org/drawingml/2006/main" xmlns:r="http://schemas.openxmlformats.org/officeDocument/2006/relationships" xmlns:p="http://schemas.openxmlformats.org/presentationml/2006/main" xmlns:m="http://schemas.openxmlformats.org/officeDocument/2006/math" xmlns:a14="http://schemas.microsoft.com/office/drawing/2010/main" type="tx" showMasterSp="1" showMasterPhAnim="1">
-  <p:cSld name="BIG_NUMBER">
+  <p:cSld name="Title Slide">
     <p:spTree>
       <p:nvGrpSpPr>
         <p:cNvPr id="1" name=""/>
@@ -603,16 +836,48 @@
       </p:grpSpPr>
       <p:sp>
         <p:nvSpPr>
-          <p:cNvPr id="91" name="xx%"/>
+          <p:cNvPr id="21" name="Title Text"/>
           <p:cNvSpPr txBox="1"/>
           <p:nvPr>
-            <p:ph type="title" hasCustomPrompt="1"/>
+            <p:ph type="title"/>
           </p:nvPr>
         </p:nvSpPr>
         <p:spPr>
           <a:xfrm>
-            <a:off x="280529" y="3146311"/>
-            <a:ext cx="7668602" cy="5585102"/>
+            <a:off x="1524000" y="1122362"/>
+            <a:ext cx="9144000" cy="2387601"/>
+          </a:xfrm>
+          <a:prstGeom prst="rect">
+            <a:avLst/>
+          </a:prstGeom>
+        </p:spPr>
+        <p:txBody>
+          <a:bodyPr anchor="b"/>
+          <a:lstStyle>
+            <a:lvl1pPr algn="ctr">
+              <a:defRPr sz="6000"/>
+            </a:lvl1pPr>
+          </a:lstStyle>
+          <a:p>
+            <a:pPr/>
+            <a:r>
+              <a:t>Title Text</a:t>
+            </a:r>
+          </a:p>
+        </p:txBody>
+      </p:sp>
+      <p:sp>
+        <p:nvSpPr>
+          <p:cNvPr id="22" name="Body Level One…"/>
+          <p:cNvSpPr txBox="1"/>
+          <p:nvPr>
+            <p:ph type="body" sz="quarter" idx="1"/>
+          </p:nvPr>
+        </p:nvSpPr>
+        <p:spPr>
+          <a:xfrm>
+            <a:off x="1524000" y="3602037"/>
+            <a:ext cx="9144000" cy="1655768"/>
           </a:xfrm>
           <a:prstGeom prst="rect">
             <a:avLst/>
@@ -621,134 +886,72 @@
         <p:txBody>
           <a:bodyPr/>
           <a:lstStyle>
-            <a:lvl1pPr>
-              <a:defRPr sz="12000"/>
+            <a:lvl1pPr marL="0" indent="0" algn="ctr">
+              <a:buSzTx/>
+              <a:buFontTx/>
+              <a:buNone/>
+              <a:defRPr sz="2400"/>
             </a:lvl1pPr>
+            <a:lvl2pPr marL="0" indent="0" algn="ctr">
+              <a:buSzTx/>
+              <a:buFontTx/>
+              <a:buNone/>
+              <a:defRPr sz="2400"/>
+            </a:lvl2pPr>
+            <a:lvl3pPr marL="0" indent="0" algn="ctr">
+              <a:buSzTx/>
+              <a:buFontTx/>
+              <a:buNone/>
+              <a:defRPr sz="2400"/>
+            </a:lvl3pPr>
+            <a:lvl4pPr marL="0" indent="0" algn="ctr">
+              <a:buSzTx/>
+              <a:buFontTx/>
+              <a:buNone/>
+              <a:defRPr sz="2400"/>
+            </a:lvl4pPr>
+            <a:lvl5pPr marL="0" indent="0" algn="ctr">
+              <a:buSzTx/>
+              <a:buFontTx/>
+              <a:buNone/>
+              <a:defRPr sz="2400"/>
+            </a:lvl5pPr>
           </a:lstStyle>
           <a:p>
             <a:pPr/>
             <a:r>
-              <a:t>xx%</a:t>
+              <a:t>Body Level One</a:t>
+            </a:r>
+          </a:p>
+          <a:p>
+            <a:pPr lvl="1"/>
+            <a:r>
+              <a:t>Body Level Two</a:t>
+            </a:r>
+          </a:p>
+          <a:p>
+            <a:pPr lvl="2"/>
+            <a:r>
+              <a:t>Body Level Three</a:t>
+            </a:r>
+          </a:p>
+          <a:p>
+            <a:pPr lvl="3"/>
+            <a:r>
+              <a:t>Body Level Four</a:t>
+            </a:r>
+          </a:p>
+          <a:p>
+            <a:pPr lvl="4"/>
+            <a:r>
+              <a:t>Body Level Five</a:t>
             </a:r>
           </a:p>
         </p:txBody>
       </p:sp>
       <p:sp>
         <p:nvSpPr>
-          <p:cNvPr id="92" name="Body Level One…"/>
-          <p:cNvSpPr txBox="1"/>
-          <p:nvPr>
-            <p:ph type="body" sz="half" idx="1"/>
-          </p:nvPr>
-        </p:nvSpPr>
-        <p:spPr>
-          <a:xfrm>
-            <a:off x="280529" y="8966327"/>
-            <a:ext cx="7668602" cy="3700202"/>
-          </a:xfrm>
-          <a:prstGeom prst="rect">
-            <a:avLst/>
-          </a:prstGeom>
-        </p:spPr>
-        <p:txBody>
-          <a:bodyPr/>
-          <a:lstStyle>
-            <a:lvl1pPr marL="457200" indent="-342900">
-              <a:lnSpc>
-                <a:spcPct val="115000"/>
-              </a:lnSpc>
-              <a:buClr>
-                <a:srgbClr val="585858"/>
-              </a:buClr>
-              <a:buSzPts val="1800"/>
-              <a:buFont typeface="Arial"/>
-              <a:buChar char="●"/>
-              <a:defRPr sz="1800"/>
-            </a:lvl1pPr>
-            <a:lvl2pPr marL="1005114" indent="-408213">
-              <a:lnSpc>
-                <a:spcPct val="115000"/>
-              </a:lnSpc>
-              <a:buClr>
-                <a:srgbClr val="585858"/>
-              </a:buClr>
-              <a:buSzPts val="1800"/>
-              <a:buFont typeface="Arial"/>
-              <a:buChar char="○"/>
-              <a:defRPr sz="1800"/>
-            </a:lvl2pPr>
-            <a:lvl3pPr marL="1462314" indent="-408214">
-              <a:lnSpc>
-                <a:spcPct val="115000"/>
-              </a:lnSpc>
-              <a:buClr>
-                <a:srgbClr val="585858"/>
-              </a:buClr>
-              <a:buSzPts val="1800"/>
-              <a:buFont typeface="Arial"/>
-              <a:buChar char="■"/>
-              <a:defRPr sz="1800"/>
-            </a:lvl3pPr>
-            <a:lvl4pPr marL="1919514" indent="-408214">
-              <a:lnSpc>
-                <a:spcPct val="115000"/>
-              </a:lnSpc>
-              <a:buClr>
-                <a:srgbClr val="585858"/>
-              </a:buClr>
-              <a:buSzPts val="1800"/>
-              <a:buFont typeface="Arial"/>
-              <a:buChar char="●"/>
-              <a:defRPr sz="1800"/>
-            </a:lvl4pPr>
-            <a:lvl5pPr marL="2376714" indent="-408214">
-              <a:lnSpc>
-                <a:spcPct val="115000"/>
-              </a:lnSpc>
-              <a:buClr>
-                <a:srgbClr val="585858"/>
-              </a:buClr>
-              <a:buSzPts val="1800"/>
-              <a:buFont typeface="Arial"/>
-              <a:buChar char="○"/>
-              <a:defRPr sz="1800"/>
-            </a:lvl5pPr>
-          </a:lstStyle>
-          <a:p>
-            <a:pPr/>
-            <a:r>
-              <a:t>Body Level One</a:t>
-            </a:r>
-          </a:p>
-          <a:p>
-            <a:pPr lvl="1"/>
-            <a:r>
-              <a:t>Body Level Two</a:t>
-            </a:r>
-          </a:p>
-          <a:p>
-            <a:pPr lvl="2"/>
-            <a:r>
-              <a:t>Body Level Three</a:t>
-            </a:r>
-          </a:p>
-          <a:p>
-            <a:pPr lvl="3"/>
-            <a:r>
-              <a:t>Body Level Four</a:t>
-            </a:r>
-          </a:p>
-          <a:p>
-            <a:pPr lvl="4"/>
-            <a:r>
-              <a:t>Body Level Five</a:t>
-            </a:r>
-          </a:p>
-        </p:txBody>
-      </p:sp>
-      <p:sp>
-        <p:nvSpPr>
-          <p:cNvPr id="93" name="Slide Number"/>
+          <p:cNvPr id="23" name="Slide Number"/>
           <p:cNvSpPr txBox="1"/>
           <p:nvPr>
             <p:ph type="sldNum" sz="quarter" idx="2"/>
@@ -777,122 +980,9 @@
 </p:sldLayout>
 </file>
 
-<file path=ppt/slideLayouts/slideLayout11.xml><?xml version="1.0" encoding="utf-8"?>
+<file path=ppt/slideLayouts/slideLayout3.xml><?xml version="1.0" encoding="utf-8"?>
 <p:sldLayout xmlns:a="http://schemas.openxmlformats.org/drawingml/2006/main" xmlns:r="http://schemas.openxmlformats.org/officeDocument/2006/relationships" xmlns:p="http://schemas.openxmlformats.org/presentationml/2006/main" xmlns:m="http://schemas.openxmlformats.org/officeDocument/2006/math" xmlns:a14="http://schemas.microsoft.com/office/drawing/2010/main" type="tx" showMasterSp="1" showMasterPhAnim="1">
-  <p:cSld name="BLANK">
-    <p:bg>
-      <p:bgPr>
-        <a:solidFill>
-          <a:srgbClr val="EBE3AC"/>
-        </a:solidFill>
-      </p:bgPr>
-    </p:bg>
-    <p:spTree>
-      <p:nvGrpSpPr>
-        <p:cNvPr id="1" name=""/>
-        <p:cNvGrpSpPr/>
-        <p:nvPr/>
-      </p:nvGrpSpPr>
-      <p:grpSpPr>
-        <a:xfrm>
-          <a:off x="0" y="0"/>
-          <a:ext cx="0" cy="0"/>
-          <a:chOff x="0" y="0"/>
-          <a:chExt cx="0" cy="0"/>
-        </a:xfrm>
-      </p:grpSpPr>
-      <p:pic>
-        <p:nvPicPr>
-          <p:cNvPr id="100" name="unknown.png" descr="unknown.png"/>
-          <p:cNvPicPr>
-            <a:picLocks noChangeAspect="1"/>
-          </p:cNvPicPr>
-          <p:nvPr/>
-        </p:nvPicPr>
-        <p:blipFill>
-          <a:blip r:embed="rId2">
-            <a:extLst/>
-          </a:blip>
-          <a:stretch>
-            <a:fillRect/>
-          </a:stretch>
-        </p:blipFill>
-        <p:spPr>
-          <a:xfrm>
-            <a:off x="5321467" y="69045"/>
-            <a:ext cx="2884696" cy="1201958"/>
-          </a:xfrm>
-          <a:prstGeom prst="rect">
-            <a:avLst/>
-          </a:prstGeom>
-          <a:ln w="12700">
-            <a:miter lim="400000"/>
-          </a:ln>
-        </p:spPr>
-      </p:pic>
-      <p:pic>
-        <p:nvPicPr>
-          <p:cNvPr id="101" name="Screenshot 2026-04-23 at 12.59.31 AM.png" descr="Screenshot 2026-04-23 at 12.59.31 AM.png"/>
-          <p:cNvPicPr>
-            <a:picLocks noChangeAspect="1"/>
-          </p:cNvPicPr>
-          <p:nvPr/>
-        </p:nvPicPr>
-        <p:blipFill>
-          <a:blip r:embed="rId3">
-            <a:extLst/>
-          </a:blip>
-          <a:stretch>
-            <a:fillRect/>
-          </a:stretch>
-        </p:blipFill>
-        <p:spPr>
-          <a:xfrm>
-            <a:off x="198400" y="237716"/>
-            <a:ext cx="4619110" cy="1808139"/>
-          </a:xfrm>
-          <a:prstGeom prst="rect">
-            <a:avLst/>
-          </a:prstGeom>
-          <a:ln w="12700">
-            <a:miter lim="400000"/>
-          </a:ln>
-        </p:spPr>
-      </p:pic>
-      <p:sp>
-        <p:nvSpPr>
-          <p:cNvPr id="102" name="Slide Number"/>
-          <p:cNvSpPr txBox="1"/>
-          <p:nvPr>
-            <p:ph type="sldNum" sz="quarter" idx="2"/>
-          </p:nvPr>
-        </p:nvSpPr>
-        <p:spPr>
-          <a:prstGeom prst="rect">
-            <a:avLst/>
-          </a:prstGeom>
-        </p:spPr>
-        <p:txBody>
-          <a:bodyPr/>
-          <a:lstStyle/>
-          <a:p>
-            <a:pPr/>
-            <a:fld id="{86CB4B4D-7CA3-9044-876B-883B54F8677D}" type="slidenum"/>
-          </a:p>
-        </p:txBody>
-      </p:sp>
-    </p:spTree>
-  </p:cSld>
-  <p:clrMapOvr>
-    <a:masterClrMapping/>
-  </p:clrMapOvr>
-  <p:transition xmlns:p14="http://schemas.microsoft.com/office/powerpoint/2010/main" spd="med" advClick="1"/>
-</p:sldLayout>
-</file>
-
-<file path=ppt/slideLayouts/slideLayout2.xml><?xml version="1.0" encoding="utf-8"?>
-<p:sldLayout xmlns:a="http://schemas.openxmlformats.org/drawingml/2006/main" xmlns:r="http://schemas.openxmlformats.org/officeDocument/2006/relationships" xmlns:p="http://schemas.openxmlformats.org/presentationml/2006/main" xmlns:m="http://schemas.openxmlformats.org/officeDocument/2006/math" xmlns:a14="http://schemas.microsoft.com/office/drawing/2010/main" type="tx" showMasterSp="1" showMasterPhAnim="1">
-  <p:cSld name="SECTION_HEADER">
+  <p:cSld name="Title and Content">
     <p:spTree>
       <p:nvGrpSpPr>
         <p:cNvPr id="1" name=""/>
@@ -909,28 +999,20 @@
       </p:grpSpPr>
       <p:sp>
         <p:nvSpPr>
-          <p:cNvPr id="20" name="Title Text"/>
+          <p:cNvPr id="30" name="Title Text"/>
           <p:cNvSpPr txBox="1"/>
           <p:nvPr>
             <p:ph type="title"/>
           </p:nvPr>
         </p:nvSpPr>
         <p:spPr>
-          <a:xfrm>
-            <a:off x="280529" y="6117973"/>
-            <a:ext cx="7668602" cy="2394602"/>
-          </a:xfrm>
           <a:prstGeom prst="rect">
             <a:avLst/>
           </a:prstGeom>
         </p:spPr>
         <p:txBody>
-          <a:bodyPr anchor="ctr"/>
-          <a:lstStyle>
-            <a:lvl1pPr>
-              <a:defRPr sz="3600"/>
-            </a:lvl1pPr>
-          </a:lstStyle>
+          <a:bodyPr/>
+          <a:lstStyle/>
           <a:p>
             <a:pPr/>
             <a:r>
@@ -941,7 +1023,55 @@
       </p:sp>
       <p:sp>
         <p:nvSpPr>
-          <p:cNvPr id="21" name="Slide Number"/>
+          <p:cNvPr id="31" name="Body Level One…"/>
+          <p:cNvSpPr txBox="1"/>
+          <p:nvPr>
+            <p:ph type="body" idx="1"/>
+          </p:nvPr>
+        </p:nvSpPr>
+        <p:spPr>
+          <a:prstGeom prst="rect">
+            <a:avLst/>
+          </a:prstGeom>
+        </p:spPr>
+        <p:txBody>
+          <a:bodyPr/>
+          <a:lstStyle/>
+          <a:p>
+            <a:pPr/>
+            <a:r>
+              <a:t>Body Level One</a:t>
+            </a:r>
+          </a:p>
+          <a:p>
+            <a:pPr lvl="1"/>
+            <a:r>
+              <a:t>Body Level Two</a:t>
+            </a:r>
+          </a:p>
+          <a:p>
+            <a:pPr lvl="2"/>
+            <a:r>
+              <a:t>Body Level Three</a:t>
+            </a:r>
+          </a:p>
+          <a:p>
+            <a:pPr lvl="3"/>
+            <a:r>
+              <a:t>Body Level Four</a:t>
+            </a:r>
+          </a:p>
+          <a:p>
+            <a:pPr lvl="4"/>
+            <a:r>
+              <a:t>Body Level Five</a:t>
+            </a:r>
+          </a:p>
+        </p:txBody>
+      </p:sp>
+      <p:sp>
+        <p:nvSpPr>
+          <p:cNvPr id="32" name="Slide Number"/>
           <p:cNvSpPr txBox="1"/>
           <p:nvPr>
             <p:ph type="sldNum" sz="quarter" idx="2"/>
@@ -970,9 +1100,9 @@
 </p:sldLayout>
 </file>
 
-<file path=ppt/slideLayouts/slideLayout3.xml><?xml version="1.0" encoding="utf-8"?>
+<file path=ppt/slideLayouts/slideLayout4.xml><?xml version="1.0" encoding="utf-8"?>
 <p:sldLayout xmlns:a="http://schemas.openxmlformats.org/drawingml/2006/main" xmlns:r="http://schemas.openxmlformats.org/officeDocument/2006/relationships" xmlns:p="http://schemas.openxmlformats.org/presentationml/2006/main" xmlns:m="http://schemas.openxmlformats.org/officeDocument/2006/math" xmlns:a14="http://schemas.microsoft.com/office/drawing/2010/main" type="tx" showMasterSp="1" showMasterPhAnim="1">
-  <p:cSld name="TITLE_AND_BODY">
+  <p:cSld name="Section Header">
     <p:spTree>
       <p:nvGrpSpPr>
         <p:cNvPr id="1" name=""/>
@@ -989,7 +1119,7 @@
       </p:grpSpPr>
       <p:sp>
         <p:nvSpPr>
-          <p:cNvPr id="28" name="Title Text"/>
+          <p:cNvPr id="39" name="Title Text"/>
           <p:cNvSpPr txBox="1"/>
           <p:nvPr>
             <p:ph type="title"/>
@@ -997,18 +1127,18 @@
         </p:nvSpPr>
         <p:spPr>
           <a:xfrm>
-            <a:off x="280529" y="1265848"/>
-            <a:ext cx="7668602" cy="1629001"/>
+            <a:off x="831850" y="1709738"/>
+            <a:ext cx="10515600" cy="2852737"/>
           </a:xfrm>
           <a:prstGeom prst="rect">
             <a:avLst/>
           </a:prstGeom>
         </p:spPr>
         <p:txBody>
-          <a:bodyPr anchor="t"/>
+          <a:bodyPr anchor="b"/>
           <a:lstStyle>
-            <a:lvl1pPr algn="l">
-              <a:defRPr sz="2800"/>
+            <a:lvl1pPr>
+              <a:defRPr sz="6000"/>
             </a:lvl1pPr>
           </a:lstStyle>
           <a:p>
@@ -1021,16 +1151,16 @@
       </p:sp>
       <p:sp>
         <p:nvSpPr>
-          <p:cNvPr id="29" name="Body Level One…"/>
+          <p:cNvPr id="40" name="Body Level One…"/>
           <p:cNvSpPr txBox="1"/>
           <p:nvPr>
-            <p:ph type="body" idx="1"/>
+            <p:ph type="body" sz="quarter" idx="1"/>
           </p:nvPr>
         </p:nvSpPr>
         <p:spPr>
           <a:xfrm>
-            <a:off x="280529" y="3278151"/>
-            <a:ext cx="7668602" cy="9717900"/>
+            <a:off x="831850" y="4589462"/>
+            <a:ext cx="10515600" cy="1500193"/>
           </a:xfrm>
           <a:prstGeom prst="rect">
             <a:avLst/>
@@ -1039,65 +1169,55 @@
         <p:txBody>
           <a:bodyPr/>
           <a:lstStyle>
-            <a:lvl1pPr marL="457200" indent="-342900" algn="l">
-              <a:lnSpc>
-                <a:spcPct val="115000"/>
-              </a:lnSpc>
-              <a:buClr>
-                <a:srgbClr val="585858"/>
-              </a:buClr>
-              <a:buSzPts val="1800"/>
-              <a:buFont typeface="Arial"/>
-              <a:buChar char="●"/>
-              <a:defRPr sz="1800"/>
+            <a:lvl1pPr marL="0" indent="0">
+              <a:buSzTx/>
+              <a:buFontTx/>
+              <a:buNone/>
+              <a:defRPr sz="2400">
+                <a:solidFill>
+                  <a:srgbClr val="757575"/>
+                </a:solidFill>
+              </a:defRPr>
             </a:lvl1pPr>
-            <a:lvl2pPr marL="1005114" indent="-408213" algn="l">
-              <a:lnSpc>
-                <a:spcPct val="115000"/>
-              </a:lnSpc>
-              <a:buClr>
-                <a:srgbClr val="585858"/>
-              </a:buClr>
-              <a:buSzPts val="1800"/>
-              <a:buFont typeface="Arial"/>
-              <a:buChar char="○"/>
-              <a:defRPr sz="1800"/>
+            <a:lvl2pPr marL="0" indent="0">
+              <a:buSzTx/>
+              <a:buFontTx/>
+              <a:buNone/>
+              <a:defRPr sz="2400">
+                <a:solidFill>
+                  <a:srgbClr val="757575"/>
+                </a:solidFill>
+              </a:defRPr>
             </a:lvl2pPr>
-            <a:lvl3pPr marL="1462314" indent="-408214" algn="l">
-              <a:lnSpc>
-                <a:spcPct val="115000"/>
-              </a:lnSpc>
-              <a:buClr>
-                <a:srgbClr val="585858"/>
-              </a:buClr>
-              <a:buSzPts val="1800"/>
-              <a:buFont typeface="Arial"/>
-              <a:buChar char="■"/>
-              <a:defRPr sz="1800"/>
+            <a:lvl3pPr marL="0" indent="0">
+              <a:buSzTx/>
+              <a:buFontTx/>
+              <a:buNone/>
+              <a:defRPr sz="2400">
+                <a:solidFill>
+                  <a:srgbClr val="757575"/>
+                </a:solidFill>
+              </a:defRPr>
             </a:lvl3pPr>
-            <a:lvl4pPr marL="1919514" indent="-408214" algn="l">
-              <a:lnSpc>
-                <a:spcPct val="115000"/>
-              </a:lnSpc>
-              <a:buClr>
-                <a:srgbClr val="585858"/>
-              </a:buClr>
-              <a:buSzPts val="1800"/>
-              <a:buFont typeface="Arial"/>
-              <a:buChar char="●"/>
-              <a:defRPr sz="1800"/>
+            <a:lvl4pPr marL="0" indent="0">
+              <a:buSzTx/>
+              <a:buFontTx/>
+              <a:buNone/>
+              <a:defRPr sz="2400">
+                <a:solidFill>
+                  <a:srgbClr val="757575"/>
+                </a:solidFill>
+              </a:defRPr>
             </a:lvl4pPr>
-            <a:lvl5pPr marL="2376714" indent="-408214" algn="l">
-              <a:lnSpc>
-                <a:spcPct val="115000"/>
-              </a:lnSpc>
-              <a:buClr>
-                <a:srgbClr val="585858"/>
-              </a:buClr>
-              <a:buSzPts val="1800"/>
-              <a:buFont typeface="Arial"/>
-              <a:buChar char="○"/>
-              <a:defRPr sz="1800"/>
+            <a:lvl5pPr marL="0" indent="0">
+              <a:buSzTx/>
+              <a:buFontTx/>
+              <a:buNone/>
+              <a:defRPr sz="2400">
+                <a:solidFill>
+                  <a:srgbClr val="757575"/>
+                </a:solidFill>
+              </a:defRPr>
             </a:lvl5pPr>
           </a:lstStyle>
           <a:p>
@@ -1134,7 +1254,7 @@
       </p:sp>
       <p:sp>
         <p:nvSpPr>
-          <p:cNvPr id="30" name="Slide Number"/>
+          <p:cNvPr id="41" name="Slide Number"/>
           <p:cNvSpPr txBox="1"/>
           <p:nvPr>
             <p:ph type="sldNum" sz="quarter" idx="2"/>
@@ -1163,9 +1283,9 @@
 </p:sldLayout>
 </file>
 
-<file path=ppt/slideLayouts/slideLayout4.xml><?xml version="1.0" encoding="utf-8"?>
+<file path=ppt/slideLayouts/slideLayout5.xml><?xml version="1.0" encoding="utf-8"?>
 <p:sldLayout xmlns:a="http://schemas.openxmlformats.org/drawingml/2006/main" xmlns:r="http://schemas.openxmlformats.org/officeDocument/2006/relationships" xmlns:p="http://schemas.openxmlformats.org/presentationml/2006/main" xmlns:m="http://schemas.openxmlformats.org/officeDocument/2006/math" xmlns:a14="http://schemas.microsoft.com/office/drawing/2010/main" type="tx" showMasterSp="1" showMasterPhAnim="1">
-  <p:cSld name="TITLE_AND_TWO_COLUMNS">
+  <p:cSld name="Two Content">
     <p:spTree>
       <p:nvGrpSpPr>
         <p:cNvPr id="1" name=""/>
@@ -1182,28 +1302,20 @@
       </p:grpSpPr>
       <p:sp>
         <p:nvSpPr>
-          <p:cNvPr id="37" name="Title Text"/>
+          <p:cNvPr id="48" name="Title Text"/>
           <p:cNvSpPr txBox="1"/>
           <p:nvPr>
             <p:ph type="title"/>
           </p:nvPr>
         </p:nvSpPr>
         <p:spPr>
-          <a:xfrm>
-            <a:off x="280529" y="1265848"/>
-            <a:ext cx="7668602" cy="1629001"/>
-          </a:xfrm>
           <a:prstGeom prst="rect">
             <a:avLst/>
           </a:prstGeom>
         </p:spPr>
         <p:txBody>
-          <a:bodyPr anchor="t"/>
-          <a:lstStyle>
-            <a:lvl1pPr algn="l">
-              <a:defRPr sz="2800"/>
-            </a:lvl1pPr>
-          </a:lstStyle>
+          <a:bodyPr/>
+          <a:lstStyle/>
           <a:p>
             <a:pPr/>
             <a:r>
@@ -1214,7 +1326,7 @@
       </p:sp>
       <p:sp>
         <p:nvSpPr>
-          <p:cNvPr id="38" name="Body Level One…"/>
+          <p:cNvPr id="49" name="Body Level One…"/>
           <p:cNvSpPr txBox="1"/>
           <p:nvPr>
             <p:ph type="body" sz="half" idx="1"/>
@@ -1222,121 +1334,8 @@
         </p:nvSpPr>
         <p:spPr>
           <a:xfrm>
-            <a:off x="280529" y="3278151"/>
-            <a:ext cx="3600002" cy="9717900"/>
-          </a:xfrm>
-          <a:prstGeom prst="rect">
-            <a:avLst/>
-          </a:prstGeom>
-        </p:spPr>
-        <p:txBody>
-          <a:bodyPr/>
-          <a:lstStyle>
-            <a:lvl1pPr marL="457200" indent="-317500" algn="l">
-              <a:lnSpc>
-                <a:spcPct val="115000"/>
-              </a:lnSpc>
-              <a:buClr>
-                <a:srgbClr val="585858"/>
-              </a:buClr>
-              <a:buSzPts val="1400"/>
-              <a:buFont typeface="Arial"/>
-              <a:buChar char="●"/>
-              <a:defRPr sz="1400"/>
-            </a:lvl1pPr>
-            <a:lvl2pPr marL="965200" indent="-355600" algn="l">
-              <a:lnSpc>
-                <a:spcPct val="115000"/>
-              </a:lnSpc>
-              <a:buClr>
-                <a:srgbClr val="585858"/>
-              </a:buClr>
-              <a:buSzPts val="1400"/>
-              <a:buFont typeface="Arial"/>
-              <a:buChar char="○"/>
-              <a:defRPr sz="1400"/>
-            </a:lvl2pPr>
-            <a:lvl3pPr marL="1422400" indent="-355600" algn="l">
-              <a:lnSpc>
-                <a:spcPct val="115000"/>
-              </a:lnSpc>
-              <a:buClr>
-                <a:srgbClr val="585858"/>
-              </a:buClr>
-              <a:buSzPts val="1400"/>
-              <a:buFont typeface="Arial"/>
-              <a:buChar char="■"/>
-              <a:defRPr sz="1400"/>
-            </a:lvl3pPr>
-            <a:lvl4pPr marL="1879600" indent="-355600" algn="l">
-              <a:lnSpc>
-                <a:spcPct val="115000"/>
-              </a:lnSpc>
-              <a:buClr>
-                <a:srgbClr val="585858"/>
-              </a:buClr>
-              <a:buSzPts val="1400"/>
-              <a:buFont typeface="Arial"/>
-              <a:buChar char="●"/>
-              <a:defRPr sz="1400"/>
-            </a:lvl4pPr>
-            <a:lvl5pPr marL="2336800" indent="-355600" algn="l">
-              <a:lnSpc>
-                <a:spcPct val="115000"/>
-              </a:lnSpc>
-              <a:buClr>
-                <a:srgbClr val="585858"/>
-              </a:buClr>
-              <a:buSzPts val="1400"/>
-              <a:buFont typeface="Arial"/>
-              <a:buChar char="○"/>
-              <a:defRPr sz="1400"/>
-            </a:lvl5pPr>
-          </a:lstStyle>
-          <a:p>
-            <a:pPr/>
-            <a:r>
-              <a:t>Body Level One</a:t>
-            </a:r>
-          </a:p>
-          <a:p>
-            <a:pPr lvl="1"/>
-            <a:r>
-              <a:t>Body Level Two</a:t>
-            </a:r>
-          </a:p>
-          <a:p>
-            <a:pPr lvl="2"/>
-            <a:r>
-              <a:t>Body Level Three</a:t>
-            </a:r>
-          </a:p>
-          <a:p>
-            <a:pPr lvl="3"/>
-            <a:r>
-              <a:t>Body Level Four</a:t>
-            </a:r>
-          </a:p>
-          <a:p>
-            <a:pPr lvl="4"/>
-            <a:r>
-              <a:t>Body Level Five</a:t>
-            </a:r>
-          </a:p>
-        </p:txBody>
-      </p:sp>
-      <p:sp>
-        <p:nvSpPr>
-          <p:cNvPr id="39" name="Google Shape;23;p5"/>
-          <p:cNvSpPr txBox="1"/>
-          <p:nvPr>
-            <p:ph type="body" sz="half" idx="21"/>
-          </p:nvPr>
-        </p:nvSpPr>
-        <p:spPr>
-          <a:xfrm>
-            <a:off x="4349160" y="3278151"/>
-            <a:ext cx="3600002" cy="9717900"/>
+            <a:off x="838200" y="1825625"/>
+            <a:ext cx="5181600" cy="4351338"/>
           </a:xfrm>
           <a:prstGeom prst="rect">
             <a:avLst/>
@@ -1347,12 +1346,39 @@
           <a:lstStyle/>
           <a:p>
             <a:pPr/>
+            <a:r>
+              <a:t>Body Level One</a:t>
+            </a:r>
+          </a:p>
+          <a:p>
+            <a:pPr lvl="1"/>
+            <a:r>
+              <a:t>Body Level Two</a:t>
+            </a:r>
+          </a:p>
+          <a:p>
+            <a:pPr lvl="2"/>
+            <a:r>
+              <a:t>Body Level Three</a:t>
+            </a:r>
+          </a:p>
+          <a:p>
+            <a:pPr lvl="3"/>
+            <a:r>
+              <a:t>Body Level Four</a:t>
+            </a:r>
+          </a:p>
+          <a:p>
+            <a:pPr lvl="4"/>
+            <a:r>
+              <a:t>Body Level Five</a:t>
+            </a:r>
           </a:p>
         </p:txBody>
       </p:sp>
       <p:sp>
         <p:nvSpPr>
-          <p:cNvPr id="40" name="Slide Number"/>
+          <p:cNvPr id="50" name="Slide Number"/>
           <p:cNvSpPr txBox="1"/>
           <p:nvPr>
             <p:ph type="sldNum" sz="quarter" idx="2"/>
@@ -1381,9 +1407,9 @@
 </p:sldLayout>
 </file>
 
-<file path=ppt/slideLayouts/slideLayout5.xml><?xml version="1.0" encoding="utf-8"?>
+<file path=ppt/slideLayouts/slideLayout6.xml><?xml version="1.0" encoding="utf-8"?>
 <p:sldLayout xmlns:a="http://schemas.openxmlformats.org/drawingml/2006/main" xmlns:r="http://schemas.openxmlformats.org/officeDocument/2006/relationships" xmlns:p="http://schemas.openxmlformats.org/presentationml/2006/main" xmlns:m="http://schemas.openxmlformats.org/officeDocument/2006/math" xmlns:a14="http://schemas.microsoft.com/office/drawing/2010/main" type="tx" showMasterSp="1" showMasterPhAnim="1">
-  <p:cSld name="TITLE_ONLY">
+  <p:cSld name="Comparison">
     <p:spTree>
       <p:nvGrpSpPr>
         <p:cNvPr id="1" name=""/>
@@ -1400,7 +1426,7 @@
       </p:grpSpPr>
       <p:sp>
         <p:nvSpPr>
-          <p:cNvPr id="47" name="Title Text"/>
+          <p:cNvPr id="57" name="Title Text"/>
           <p:cNvSpPr txBox="1"/>
           <p:nvPr>
             <p:ph type="title"/>
@@ -1408,20 +1434,16 @@
         </p:nvSpPr>
         <p:spPr>
           <a:xfrm>
-            <a:off x="280529" y="1265848"/>
-            <a:ext cx="7668602" cy="1629001"/>
+            <a:off x="839787" y="365125"/>
+            <a:ext cx="10515601" cy="1325563"/>
           </a:xfrm>
           <a:prstGeom prst="rect">
             <a:avLst/>
           </a:prstGeom>
         </p:spPr>
         <p:txBody>
-          <a:bodyPr anchor="t"/>
-          <a:lstStyle>
-            <a:lvl1pPr algn="l">
-              <a:defRPr sz="2800"/>
-            </a:lvl1pPr>
-          </a:lstStyle>
+          <a:bodyPr/>
+          <a:lstStyle/>
           <a:p>
             <a:pPr/>
             <a:r>
@@ -1432,7 +1454,115 @@
       </p:sp>
       <p:sp>
         <p:nvSpPr>
-          <p:cNvPr id="48" name="Slide Number"/>
+          <p:cNvPr id="58" name="Body Level One…"/>
+          <p:cNvSpPr txBox="1"/>
+          <p:nvPr>
+            <p:ph type="body" sz="quarter" idx="1"/>
+          </p:nvPr>
+        </p:nvSpPr>
+        <p:spPr>
+          <a:xfrm>
+            <a:off x="839787" y="1681163"/>
+            <a:ext cx="5157790" cy="823918"/>
+          </a:xfrm>
+          <a:prstGeom prst="rect">
+            <a:avLst/>
+          </a:prstGeom>
+        </p:spPr>
+        <p:txBody>
+          <a:bodyPr anchor="b"/>
+          <a:lstStyle>
+            <a:lvl1pPr marL="0" indent="0">
+              <a:buSzTx/>
+              <a:buFontTx/>
+              <a:buNone/>
+              <a:defRPr b="1" sz="2400"/>
+            </a:lvl1pPr>
+            <a:lvl2pPr marL="0" indent="0">
+              <a:buSzTx/>
+              <a:buFontTx/>
+              <a:buNone/>
+              <a:defRPr b="1" sz="2400"/>
+            </a:lvl2pPr>
+            <a:lvl3pPr marL="0" indent="0">
+              <a:buSzTx/>
+              <a:buFontTx/>
+              <a:buNone/>
+              <a:defRPr b="1" sz="2400"/>
+            </a:lvl3pPr>
+            <a:lvl4pPr marL="0" indent="0">
+              <a:buSzTx/>
+              <a:buFontTx/>
+              <a:buNone/>
+              <a:defRPr b="1" sz="2400"/>
+            </a:lvl4pPr>
+            <a:lvl5pPr marL="0" indent="0">
+              <a:buSzTx/>
+              <a:buFontTx/>
+              <a:buNone/>
+              <a:defRPr b="1" sz="2400"/>
+            </a:lvl5pPr>
+          </a:lstStyle>
+          <a:p>
+            <a:pPr/>
+            <a:r>
+              <a:t>Body Level One</a:t>
+            </a:r>
+          </a:p>
+          <a:p>
+            <a:pPr lvl="1"/>
+            <a:r>
+              <a:t>Body Level Two</a:t>
+            </a:r>
+          </a:p>
+          <a:p>
+            <a:pPr lvl="2"/>
+            <a:r>
+              <a:t>Body Level Three</a:t>
+            </a:r>
+          </a:p>
+          <a:p>
+            <a:pPr lvl="3"/>
+            <a:r>
+              <a:t>Body Level Four</a:t>
+            </a:r>
+          </a:p>
+          <a:p>
+            <a:pPr lvl="4"/>
+            <a:r>
+              <a:t>Body Level Five</a:t>
+            </a:r>
+          </a:p>
+        </p:txBody>
+      </p:sp>
+      <p:sp>
+        <p:nvSpPr>
+          <p:cNvPr id="59" name="Text Placeholder 4"/>
+          <p:cNvSpPr/>
+          <p:nvPr>
+            <p:ph type="body" sz="quarter" idx="21"/>
+          </p:nvPr>
+        </p:nvSpPr>
+        <p:spPr>
+          <a:xfrm>
+            <a:off x="6172200" y="1681163"/>
+            <a:ext cx="5183188" cy="823914"/>
+          </a:xfrm>
+          <a:prstGeom prst="rect">
+            <a:avLst/>
+          </a:prstGeom>
+        </p:spPr>
+        <p:txBody>
+          <a:bodyPr anchor="b"/>
+          <a:lstStyle/>
+          <a:p>
+            <a:pPr/>
+          </a:p>
+        </p:txBody>
+      </p:sp>
+      <p:sp>
+        <p:nvSpPr>
+          <p:cNvPr id="60" name="Slide Number"/>
           <p:cNvSpPr txBox="1"/>
           <p:nvPr>
             <p:ph type="sldNum" sz="quarter" idx="2"/>
@@ -1461,9 +1591,9 @@
 </p:sldLayout>
 </file>
 
-<file path=ppt/slideLayouts/slideLayout6.xml><?xml version="1.0" encoding="utf-8"?>
+<file path=ppt/slideLayouts/slideLayout7.xml><?xml version="1.0" encoding="utf-8"?>
 <p:sldLayout xmlns:a="http://schemas.openxmlformats.org/drawingml/2006/main" xmlns:r="http://schemas.openxmlformats.org/officeDocument/2006/relationships" xmlns:p="http://schemas.openxmlformats.org/presentationml/2006/main" xmlns:m="http://schemas.openxmlformats.org/officeDocument/2006/math" xmlns:a14="http://schemas.microsoft.com/office/drawing/2010/main" type="tx" showMasterSp="1" showMasterPhAnim="1">
-  <p:cSld name="ONE_COLUMN_TEXT">
+  <p:cSld name="Title Only">
     <p:spTree>
       <p:nvGrpSpPr>
         <p:cNvPr id="1" name=""/>
@@ -1480,28 +1610,20 @@
       </p:grpSpPr>
       <p:sp>
         <p:nvSpPr>
-          <p:cNvPr id="55" name="Title Text"/>
+          <p:cNvPr id="67" name="Title Text"/>
           <p:cNvSpPr txBox="1"/>
           <p:nvPr>
             <p:ph type="title"/>
           </p:nvPr>
         </p:nvSpPr>
         <p:spPr>
-          <a:xfrm>
-            <a:off x="280529" y="1580373"/>
-            <a:ext cx="2527202" cy="2149501"/>
-          </a:xfrm>
           <a:prstGeom prst="rect">
             <a:avLst/>
           </a:prstGeom>
         </p:spPr>
         <p:txBody>
           <a:bodyPr/>
-          <a:lstStyle>
-            <a:lvl1pPr algn="l">
-              <a:defRPr sz="2400"/>
-            </a:lvl1pPr>
-          </a:lstStyle>
+          <a:lstStyle/>
           <a:p>
             <a:pPr/>
             <a:r>
@@ -1512,120 +1634,7 @@
       </p:sp>
       <p:sp>
         <p:nvSpPr>
-          <p:cNvPr id="56" name="Body Level One…"/>
-          <p:cNvSpPr txBox="1"/>
-          <p:nvPr>
-            <p:ph type="body" sz="quarter" idx="1"/>
-          </p:nvPr>
-        </p:nvSpPr>
-        <p:spPr>
-          <a:xfrm>
-            <a:off x="280529" y="3952640"/>
-            <a:ext cx="2527202" cy="9043501"/>
-          </a:xfrm>
-          <a:prstGeom prst="rect">
-            <a:avLst/>
-          </a:prstGeom>
-        </p:spPr>
-        <p:txBody>
-          <a:bodyPr/>
-          <a:lstStyle>
-            <a:lvl1pPr marL="457200" indent="-304800" algn="l">
-              <a:lnSpc>
-                <a:spcPct val="115000"/>
-              </a:lnSpc>
-              <a:buClr>
-                <a:srgbClr val="585858"/>
-              </a:buClr>
-              <a:buSzPts val="1200"/>
-              <a:buFont typeface="Arial"/>
-              <a:buChar char="●"/>
-              <a:defRPr sz="1200"/>
-            </a:lvl1pPr>
-            <a:lvl2pPr marL="914400" indent="-304800" algn="l">
-              <a:lnSpc>
-                <a:spcPct val="115000"/>
-              </a:lnSpc>
-              <a:buClr>
-                <a:srgbClr val="585858"/>
-              </a:buClr>
-              <a:buSzPts val="1200"/>
-              <a:buFont typeface="Arial"/>
-              <a:buChar char="○"/>
-              <a:defRPr sz="1200"/>
-            </a:lvl2pPr>
-            <a:lvl3pPr marL="1371600" indent="-304800" algn="l">
-              <a:lnSpc>
-                <a:spcPct val="115000"/>
-              </a:lnSpc>
-              <a:buClr>
-                <a:srgbClr val="585858"/>
-              </a:buClr>
-              <a:buSzPts val="1200"/>
-              <a:buFont typeface="Arial"/>
-              <a:buChar char="■"/>
-              <a:defRPr sz="1200"/>
-            </a:lvl3pPr>
-            <a:lvl4pPr marL="1828800" indent="-304800" algn="l">
-              <a:lnSpc>
-                <a:spcPct val="115000"/>
-              </a:lnSpc>
-              <a:buClr>
-                <a:srgbClr val="585858"/>
-              </a:buClr>
-              <a:buSzPts val="1200"/>
-              <a:buFont typeface="Arial"/>
-              <a:buChar char="●"/>
-              <a:defRPr sz="1200"/>
-            </a:lvl4pPr>
-            <a:lvl5pPr marL="2286000" indent="-304800" algn="l">
-              <a:lnSpc>
-                <a:spcPct val="115000"/>
-              </a:lnSpc>
-              <a:buClr>
-                <a:srgbClr val="585858"/>
-              </a:buClr>
-              <a:buSzPts val="1200"/>
-              <a:buFont typeface="Arial"/>
-              <a:buChar char="○"/>
-              <a:defRPr sz="1200"/>
-            </a:lvl5pPr>
-          </a:lstStyle>
-          <a:p>
-            <a:pPr/>
-            <a:r>
-              <a:t>Body Level One</a:t>
-            </a:r>
-          </a:p>
-          <a:p>
-            <a:pPr lvl="1"/>
-            <a:r>
-              <a:t>Body Level Two</a:t>
-            </a:r>
-          </a:p>
-          <a:p>
-            <a:pPr lvl="2"/>
-            <a:r>
-              <a:t>Body Level Three</a:t>
-            </a:r>
-          </a:p>
-          <a:p>
-            <a:pPr lvl="3"/>
-            <a:r>
-              <a:t>Body Level Four</a:t>
-            </a:r>
-          </a:p>
-          <a:p>
-            <a:pPr lvl="4"/>
-            <a:r>
-              <a:t>Body Level Five</a:t>
-            </a:r>
-          </a:p>
-        </p:txBody>
-      </p:sp>
-      <p:sp>
-        <p:nvSpPr>
-          <p:cNvPr id="57" name="Slide Number"/>
+          <p:cNvPr id="68" name="Slide Number"/>
           <p:cNvSpPr txBox="1"/>
           <p:nvPr>
             <p:ph type="sldNum" sz="quarter" idx="2"/>
@@ -1654,9 +1663,9 @@
 </p:sldLayout>
 </file>
 
-<file path=ppt/slideLayouts/slideLayout7.xml><?xml version="1.0" encoding="utf-8"?>
+<file path=ppt/slideLayouts/slideLayout8.xml><?xml version="1.0" encoding="utf-8"?>
 <p:sldLayout xmlns:a="http://schemas.openxmlformats.org/drawingml/2006/main" xmlns:r="http://schemas.openxmlformats.org/officeDocument/2006/relationships" xmlns:p="http://schemas.openxmlformats.org/presentationml/2006/main" xmlns:m="http://schemas.openxmlformats.org/officeDocument/2006/math" xmlns:a14="http://schemas.microsoft.com/office/drawing/2010/main" type="tx" showMasterSp="1" showMasterPhAnim="1">
-  <p:cSld name="MAIN_POINT">
+  <p:cSld name="Blank">
     <p:spTree>
       <p:nvGrpSpPr>
         <p:cNvPr id="1" name=""/>
@@ -1673,39 +1682,7 @@
       </p:grpSpPr>
       <p:sp>
         <p:nvSpPr>
-          <p:cNvPr id="64" name="Title Text"/>
-          <p:cNvSpPr txBox="1"/>
-          <p:nvPr>
-            <p:ph type="title"/>
-          </p:nvPr>
-        </p:nvSpPr>
-        <p:spPr>
-          <a:xfrm>
-            <a:off x="441225" y="1280426"/>
-            <a:ext cx="5730901" cy="11636102"/>
-          </a:xfrm>
-          <a:prstGeom prst="rect">
-            <a:avLst/>
-          </a:prstGeom>
-        </p:spPr>
-        <p:txBody>
-          <a:bodyPr anchor="ctr"/>
-          <a:lstStyle>
-            <a:lvl1pPr algn="l">
-              <a:defRPr sz="4800"/>
-            </a:lvl1pPr>
-          </a:lstStyle>
-          <a:p>
-            <a:pPr/>
-            <a:r>
-              <a:t>Title Text</a:t>
-            </a:r>
-          </a:p>
-        </p:txBody>
-      </p:sp>
-      <p:sp>
-        <p:nvSpPr>
-          <p:cNvPr id="65" name="Slide Number"/>
+          <p:cNvPr id="75" name="Slide Number"/>
           <p:cNvSpPr txBox="1"/>
           <p:nvPr>
             <p:ph type="sldNum" sz="quarter" idx="2"/>
@@ -1734,9 +1711,9 @@
 </p:sldLayout>
 </file>
 
-<file path=ppt/slideLayouts/slideLayout8.xml><?xml version="1.0" encoding="utf-8"?>
+<file path=ppt/slideLayouts/slideLayout9.xml><?xml version="1.0" encoding="utf-8"?>
 <p:sldLayout xmlns:a="http://schemas.openxmlformats.org/drawingml/2006/main" xmlns:r="http://schemas.openxmlformats.org/officeDocument/2006/relationships" xmlns:p="http://schemas.openxmlformats.org/presentationml/2006/main" xmlns:m="http://schemas.openxmlformats.org/officeDocument/2006/math" xmlns:a14="http://schemas.microsoft.com/office/drawing/2010/main" type="tx" showMasterSp="1" showMasterPhAnim="1">
-  <p:cSld name="SECTION_TITLE_AND_DESCRIPTION">
+  <p:cSld name="Content with Caption">
     <p:spTree>
       <p:nvGrpSpPr>
         <p:cNvPr id="1" name=""/>
@@ -1753,36 +1730,7 @@
       </p:grpSpPr>
       <p:sp>
         <p:nvSpPr>
-          <p:cNvPr id="72" name="Google Shape;36;p9"/>
-          <p:cNvSpPr/>
-          <p:nvPr/>
-        </p:nvSpPr>
-        <p:spPr>
-          <a:xfrm>
-            <a:off x="4114800" y="-357"/>
-            <a:ext cx="4114800" cy="14630402"/>
-          </a:xfrm>
-          <a:prstGeom prst="rect">
-            <a:avLst/>
-          </a:prstGeom>
-          <a:solidFill>
-            <a:srgbClr val="EEEEEE"/>
-          </a:solidFill>
-          <a:ln w="12700">
-            <a:miter lim="400000"/>
-          </a:ln>
-        </p:spPr>
-        <p:txBody>
-          <a:bodyPr lIns="0" tIns="0" rIns="0" bIns="0" anchor="ctr"/>
-          <a:lstStyle/>
-          <a:p>
-            <a:pPr/>
-          </a:p>
-        </p:txBody>
-      </p:sp>
-      <p:sp>
-        <p:nvSpPr>
-          <p:cNvPr id="73" name="Title Text"/>
+          <p:cNvPr id="82" name="Title Text"/>
           <p:cNvSpPr txBox="1"/>
           <p:nvPr>
             <p:ph type="title"/>
@@ -1790,8 +1738,40 @@
         </p:nvSpPr>
         <p:spPr>
           <a:xfrm>
-            <a:off x="238949" y="3507697"/>
-            <a:ext cx="3640802" cy="4216202"/>
+            <a:off x="839787" y="457200"/>
+            <a:ext cx="3932240" cy="1600200"/>
+          </a:xfrm>
+          <a:prstGeom prst="rect">
+            <a:avLst/>
+          </a:prstGeom>
+        </p:spPr>
+        <p:txBody>
+          <a:bodyPr anchor="b"/>
+          <a:lstStyle>
+            <a:lvl1pPr>
+              <a:defRPr sz="3200"/>
+            </a:lvl1pPr>
+          </a:lstStyle>
+          <a:p>
+            <a:pPr/>
+            <a:r>
+              <a:t>Title Text</a:t>
+            </a:r>
+          </a:p>
+        </p:txBody>
+      </p:sp>
+      <p:sp>
+        <p:nvSpPr>
+          <p:cNvPr id="83" name="Body Level One…"/>
+          <p:cNvSpPr txBox="1"/>
+          <p:nvPr>
+            <p:ph type="body" sz="half" idx="1"/>
+          </p:nvPr>
+        </p:nvSpPr>
+        <p:spPr>
+          <a:xfrm>
+            <a:off x="5183187" y="987425"/>
+            <a:ext cx="6172204" cy="4873625"/>
           </a:xfrm>
           <a:prstGeom prst="rect">
             <a:avLst/>
@@ -1801,29 +1781,65 @@
           <a:bodyPr/>
           <a:lstStyle>
             <a:lvl1pPr>
-              <a:defRPr sz="4200"/>
+              <a:defRPr sz="3200"/>
             </a:lvl1pPr>
+            <a:lvl2pPr marL="718457" indent="-261257">
+              <a:defRPr sz="3200"/>
+            </a:lvl2pPr>
+            <a:lvl3pPr marL="1219200" indent="-304800">
+              <a:defRPr sz="3200"/>
+            </a:lvl3pPr>
+            <a:lvl4pPr marL="1737360" indent="-365760">
+              <a:defRPr sz="3200"/>
+            </a:lvl4pPr>
+            <a:lvl5pPr marL="2194560" indent="-365760">
+              <a:defRPr sz="3200"/>
+            </a:lvl5pPr>
           </a:lstStyle>
           <a:p>
             <a:pPr/>
             <a:r>
-              <a:t>Title Text</a:t>
+              <a:t>Body Level One</a:t>
+            </a:r>
+          </a:p>
+          <a:p>
+            <a:pPr lvl="1"/>
+            <a:r>
+              <a:t>Body Level Two</a:t>
+            </a:r>
+          </a:p>
+          <a:p>
+            <a:pPr lvl="2"/>
+            <a:r>
+              <a:t>Body Level Three</a:t>
+            </a:r>
+          </a:p>
+          <a:p>
+            <a:pPr lvl="3"/>
+            <a:r>
+              <a:t>Body Level Four</a:t>
+            </a:r>
+          </a:p>
+          <a:p>
+            <a:pPr lvl="4"/>
+            <a:r>
+              <a:t>Body Level Five</a:t>
             </a:r>
           </a:p>
         </p:txBody>
       </p:sp>
       <p:sp>
         <p:nvSpPr>
-          <p:cNvPr id="74" name="Body Level One…"/>
-          <p:cNvSpPr txBox="1"/>
+          <p:cNvPr id="84" name="Text Placeholder 3"/>
+          <p:cNvSpPr/>
           <p:nvPr>
-            <p:ph type="body" sz="quarter" idx="1"/>
+            <p:ph type="body" sz="quarter" idx="21"/>
           </p:nvPr>
         </p:nvSpPr>
         <p:spPr>
           <a:xfrm>
-            <a:off x="238949" y="7973190"/>
-            <a:ext cx="3640802" cy="3513302"/>
+            <a:off x="839784" y="2057400"/>
+            <a:ext cx="3932247" cy="3811588"/>
           </a:xfrm>
           <a:prstGeom prst="rect">
             <a:avLst/>
@@ -1831,207 +1847,15 @@
         </p:spPr>
         <p:txBody>
           <a:bodyPr/>
-          <a:lstStyle>
-            <a:lvl1pPr>
-              <a:defRPr sz="2100"/>
-            </a:lvl1pPr>
-            <a:lvl2pPr>
-              <a:defRPr sz="2100"/>
-            </a:lvl2pPr>
-            <a:lvl3pPr>
-              <a:defRPr sz="2100"/>
-            </a:lvl3pPr>
-            <a:lvl4pPr>
-              <a:defRPr sz="2100"/>
-            </a:lvl4pPr>
-            <a:lvl5pPr>
-              <a:defRPr sz="2100"/>
-            </a:lvl5pPr>
-          </a:lstStyle>
+          <a:lstStyle/>
           <a:p>
             <a:pPr/>
-            <a:r>
-              <a:t>Body Level One</a:t>
-            </a:r>
-          </a:p>
-          <a:p>
-            <a:pPr lvl="1"/>
-            <a:r>
-              <a:t>Body Level Two</a:t>
-            </a:r>
-          </a:p>
-          <a:p>
-            <a:pPr lvl="2"/>
-            <a:r>
-              <a:t>Body Level Three</a:t>
-            </a:r>
-          </a:p>
-          <a:p>
-            <a:pPr lvl="3"/>
-            <a:r>
-              <a:t>Body Level Four</a:t>
-            </a:r>
-          </a:p>
-          <a:p>
-            <a:pPr lvl="4"/>
-            <a:r>
-              <a:t>Body Level Five</a:t>
-            </a:r>
           </a:p>
         </p:txBody>
       </p:sp>
       <p:sp>
         <p:nvSpPr>
-          <p:cNvPr id="75" name="Google Shape;39;p9"/>
-          <p:cNvSpPr txBox="1"/>
-          <p:nvPr>
-            <p:ph type="body" sz="half" idx="21"/>
-          </p:nvPr>
-        </p:nvSpPr>
-        <p:spPr>
-          <a:xfrm>
-            <a:off x="4445549" y="2059589"/>
-            <a:ext cx="3453303" cy="10510503"/>
-          </a:xfrm>
-          <a:prstGeom prst="rect">
-            <a:avLst/>
-          </a:prstGeom>
-        </p:spPr>
-        <p:txBody>
-          <a:bodyPr anchor="ctr"/>
-          <a:lstStyle/>
-          <a:p>
-            <a:pPr/>
-          </a:p>
-        </p:txBody>
-      </p:sp>
-      <p:sp>
-        <p:nvSpPr>
-          <p:cNvPr id="76" name="Slide Number"/>
-          <p:cNvSpPr txBox="1"/>
-          <p:nvPr>
-            <p:ph type="sldNum" sz="quarter" idx="2"/>
-          </p:nvPr>
-        </p:nvSpPr>
-        <p:spPr>
-          <a:prstGeom prst="rect">
-            <a:avLst/>
-          </a:prstGeom>
-        </p:spPr>
-        <p:txBody>
-          <a:bodyPr/>
-          <a:lstStyle/>
-          <a:p>
-            <a:pPr/>
-            <a:fld id="{86CB4B4D-7CA3-9044-876B-883B54F8677D}" type="slidenum"/>
-          </a:p>
-        </p:txBody>
-      </p:sp>
-    </p:spTree>
-  </p:cSld>
-  <p:clrMapOvr>
-    <a:masterClrMapping/>
-  </p:clrMapOvr>
-  <p:transition xmlns:p14="http://schemas.microsoft.com/office/powerpoint/2010/main" spd="med" advClick="1"/>
-</p:sldLayout>
-</file>
-
-<file path=ppt/slideLayouts/slideLayout9.xml><?xml version="1.0" encoding="utf-8"?>
-<p:sldLayout xmlns:a="http://schemas.openxmlformats.org/drawingml/2006/main" xmlns:r="http://schemas.openxmlformats.org/officeDocument/2006/relationships" xmlns:p="http://schemas.openxmlformats.org/presentationml/2006/main" xmlns:m="http://schemas.openxmlformats.org/officeDocument/2006/math" xmlns:a14="http://schemas.microsoft.com/office/drawing/2010/main" type="tx" showMasterSp="1" showMasterPhAnim="1">
-  <p:cSld name="CAPTION_ONLY">
-    <p:spTree>
-      <p:nvGrpSpPr>
-        <p:cNvPr id="1" name=""/>
-        <p:cNvGrpSpPr/>
-        <p:nvPr/>
-      </p:nvGrpSpPr>
-      <p:grpSpPr>
-        <a:xfrm>
-          <a:off x="0" y="0"/>
-          <a:ext cx="0" cy="0"/>
-          <a:chOff x="0" y="0"/>
-          <a:chExt cx="0" cy="0"/>
-        </a:xfrm>
-      </p:grpSpPr>
-      <p:sp>
-        <p:nvSpPr>
-          <p:cNvPr id="83" name="Body Level One…"/>
-          <p:cNvSpPr txBox="1"/>
-          <p:nvPr>
-            <p:ph type="body" sz="quarter" idx="1"/>
-          </p:nvPr>
-        </p:nvSpPr>
-        <p:spPr>
-          <a:xfrm>
-            <a:off x="280529" y="12033636"/>
-            <a:ext cx="5398802" cy="1721101"/>
-          </a:xfrm>
-          <a:prstGeom prst="rect">
-            <a:avLst/>
-          </a:prstGeom>
-        </p:spPr>
-        <p:txBody>
-          <a:bodyPr anchor="ctr"/>
-          <a:lstStyle>
-            <a:lvl1pPr marL="0" indent="228600" algn="l">
-              <a:defRPr sz="1800"/>
-            </a:lvl1pPr>
-            <a:lvl2pPr marL="1005114" indent="-408213" algn="l">
-              <a:buSzPts val="1800"/>
-              <a:buChar char="○"/>
-              <a:defRPr sz="1800"/>
-            </a:lvl2pPr>
-            <a:lvl3pPr marL="1462314" indent="-408214" algn="l">
-              <a:buSzPts val="1800"/>
-              <a:buChar char="■"/>
-              <a:defRPr sz="1800"/>
-            </a:lvl3pPr>
-            <a:lvl4pPr marL="1919514" indent="-408214" algn="l">
-              <a:buSzPts val="1800"/>
-              <a:buChar char="●"/>
-              <a:defRPr sz="1800"/>
-            </a:lvl4pPr>
-            <a:lvl5pPr marL="2376714" indent="-408214" algn="l">
-              <a:buSzPts val="1800"/>
-              <a:buChar char="○"/>
-              <a:defRPr sz="1800"/>
-            </a:lvl5pPr>
-          </a:lstStyle>
-          <a:p>
-            <a:pPr/>
-            <a:r>
-              <a:t>Body Level One</a:t>
-            </a:r>
-          </a:p>
-          <a:p>
-            <a:pPr lvl="1"/>
-            <a:r>
-              <a:t>Body Level Two</a:t>
-            </a:r>
-          </a:p>
-          <a:p>
-            <a:pPr lvl="2"/>
-            <a:r>
-              <a:t>Body Level Three</a:t>
-            </a:r>
-          </a:p>
-          <a:p>
-            <a:pPr lvl="3"/>
-            <a:r>
-              <a:t>Body Level Four</a:t>
-            </a:r>
-          </a:p>
-          <a:p>
-            <a:pPr lvl="4"/>
-            <a:r>
-              <a:t>Body Level Five</a:t>
-            </a:r>
-          </a:p>
-        </p:txBody>
-      </p:sp>
-      <p:sp>
-        <p:nvSpPr>
-          <p:cNvPr id="84" name="Slide Number"/>
+          <p:cNvPr id="85" name="Slide Number"/>
           <p:cNvSpPr txBox="1"/>
           <p:nvPr>
             <p:ph type="sldNum" sz="quarter" idx="2"/>
@@ -2065,9 +1889,13 @@
   <p:cSld>
     <p:bg>
       <p:bgPr>
-        <a:solidFill>
-          <a:srgbClr val="FFFFFF"/>
-        </a:solidFill>
+        <a:blipFill rotWithShape="1">
+          <a:blip r:embed="rId2"/>
+          <a:srcRect l="0" t="0" r="0" b="0"/>
+          <a:stretch>
+            <a:fillRect/>
+          </a:stretch>
+        </a:blipFill>
       </p:bgPr>
     </p:bg>
     <p:spTree>
@@ -2094,8 +1922,8 @@
         </p:nvSpPr>
         <p:spPr>
           <a:xfrm>
-            <a:off x="280538" y="2117900"/>
-            <a:ext cx="7668601" cy="5838602"/>
+            <a:off x="838200" y="365125"/>
+            <a:ext cx="10515600" cy="1325563"/>
           </a:xfrm>
           <a:prstGeom prst="rect">
             <a:avLst/>
@@ -2110,7 +1938,7 @@
           </a:extLst>
         </p:spPr>
         <p:txBody>
-          <a:bodyPr lIns="91423" tIns="91423" rIns="91423" bIns="91423" anchor="b">
+          <a:bodyPr lIns="45718" tIns="45718" rIns="45718" bIns="45718" anchor="ctr">
             <a:normAutofit fontScale="100000" lnSpcReduction="0"/>
           </a:bodyPr>
           <a:lstStyle/>
@@ -2132,8 +1960,8 @@
         </p:nvSpPr>
         <p:spPr>
           <a:xfrm>
-            <a:off x="280529" y="8061511"/>
-            <a:ext cx="7668602" cy="2254501"/>
+            <a:off x="838200" y="1825625"/>
+            <a:ext cx="10515600" cy="4351338"/>
           </a:xfrm>
           <a:prstGeom prst="rect">
             <a:avLst/>
@@ -2148,7 +1976,7 @@
           </a:extLst>
         </p:spPr>
         <p:txBody>
-          <a:bodyPr lIns="91423" tIns="91423" rIns="91423" bIns="91423">
+          <a:bodyPr lIns="45718" tIns="45718" rIns="45718" bIns="45718">
             <a:normAutofit fontScale="100000" lnSpcReduction="0"/>
           </a:bodyPr>
           <a:lstStyle/>
@@ -2194,8 +2022,8 @@
         </p:nvSpPr>
         <p:spPr>
           <a:xfrm>
-            <a:off x="7782202" y="13664865"/>
-            <a:ext cx="336811" cy="318394"/>
+            <a:off x="11080151" y="6404294"/>
+            <a:ext cx="273653" cy="269237"/>
           </a:xfrm>
           <a:prstGeom prst="rect">
             <a:avLst/>
@@ -2205,15 +2033,19 @@
           </a:ln>
         </p:spPr>
         <p:txBody>
-          <a:bodyPr wrap="none" lIns="91423" tIns="91423" rIns="91423" bIns="91423" anchor="ctr">
-            <a:normAutofit fontScale="100000" lnSpcReduction="0"/>
+          <a:bodyPr wrap="none" lIns="45718" tIns="45718" rIns="45718" bIns="45718" anchor="ctr">
+            <a:spAutoFit/>
           </a:bodyPr>
           <a:lstStyle>
             <a:lvl1pPr algn="r">
-              <a:defRPr sz="1000">
+              <a:defRPr sz="1200">
                 <a:solidFill>
-                  <a:srgbClr val="585858"/>
+                  <a:srgbClr val="757575"/>
                 </a:solidFill>
+                <a:latin typeface="+mj-lt"/>
+                <a:ea typeface="+mj-ea"/>
+                <a:cs typeface="+mj-cs"/>
+                <a:sym typeface="Aptos"/>
               </a:defRPr>
             </a:lvl1pPr>
           </a:lstStyle>
@@ -2227,24 +2059,23 @@
   </p:cSld>
   <p:clrMap bg1="lt1" tx1="dk1" bg2="lt2" tx2="dk2" accent1="accent1" accent2="accent2" accent3="accent3" accent4="accent4" accent5="accent5" accent6="accent6" hlink="hlink" folHlink="folHlink"/>
   <p:sldLayoutIdLst>
-    <p:sldLayoutId id="2147483649" r:id="rId2"/>
-    <p:sldLayoutId id="2147483650" r:id="rId3"/>
-    <p:sldLayoutId id="2147483651" r:id="rId4"/>
-    <p:sldLayoutId id="2147483652" r:id="rId5"/>
-    <p:sldLayoutId id="2147483653" r:id="rId6"/>
-    <p:sldLayoutId id="2147483654" r:id="rId7"/>
-    <p:sldLayoutId id="2147483655" r:id="rId8"/>
-    <p:sldLayoutId id="2147483656" r:id="rId9"/>
-    <p:sldLayoutId id="2147483657" r:id="rId10"/>
-    <p:sldLayoutId id="2147483658" r:id="rId11"/>
-    <p:sldLayoutId id="2147483659" r:id="rId12"/>
+    <p:sldLayoutId id="2147483649" r:id="rId3"/>
+    <p:sldLayoutId id="2147483650" r:id="rId4"/>
+    <p:sldLayoutId id="2147483651" r:id="rId5"/>
+    <p:sldLayoutId id="2147483652" r:id="rId6"/>
+    <p:sldLayoutId id="2147483653" r:id="rId7"/>
+    <p:sldLayoutId id="2147483654" r:id="rId8"/>
+    <p:sldLayoutId id="2147483655" r:id="rId9"/>
+    <p:sldLayoutId id="2147483656" r:id="rId10"/>
+    <p:sldLayoutId id="2147483657" r:id="rId11"/>
+    <p:sldLayoutId id="2147483658" r:id="rId12"/>
   </p:sldLayoutIdLst>
   <p:transition xmlns:p14="http://schemas.microsoft.com/office/powerpoint/2010/main" spd="med" advClick="1"/>
   <p:txStyles>
     <p:titleStyle>
-      <a:lvl1pPr marL="0" marR="0" indent="0" algn="ctr" defTabSz="914400" rtl="0" latinLnBrk="0">
+      <a:lvl1pPr marL="0" marR="0" indent="0" algn="l" defTabSz="914400" rtl="0" latinLnBrk="0">
         <a:lnSpc>
-          <a:spcPct val="100000"/>
+          <a:spcPct val="90000"/>
         </a:lnSpc>
         <a:spcBef>
           <a:spcPts val="0"/>
@@ -2257,20 +2088,20 @@
         <a:buFontTx/>
         <a:buNone/>
         <a:tabLst/>
-        <a:defRPr b="0" baseline="0" cap="none" i="0" spc="0" strike="noStrike" sz="5200" u="none">
+        <a:defRPr b="0" baseline="0" cap="none" i="0" spc="0" strike="noStrike" sz="4400" u="none">
           <a:solidFill>
             <a:srgbClr val="000000"/>
           </a:solidFill>
           <a:uFillTx/>
-          <a:latin typeface="+mn-lt"/>
-          <a:ea typeface="+mn-ea"/>
-          <a:cs typeface="+mn-cs"/>
-          <a:sym typeface="Arial"/>
+          <a:latin typeface="Aptos Display"/>
+          <a:ea typeface="Aptos Display"/>
+          <a:cs typeface="Aptos Display"/>
+          <a:sym typeface="Aptos Display"/>
         </a:defRPr>
       </a:lvl1pPr>
-      <a:lvl2pPr marL="0" marR="0" indent="0" algn="ctr" defTabSz="914400" rtl="0" latinLnBrk="0">
+      <a:lvl2pPr marL="0" marR="0" indent="0" algn="l" defTabSz="914400" rtl="0" latinLnBrk="0">
         <a:lnSpc>
-          <a:spcPct val="100000"/>
+          <a:spcPct val="90000"/>
         </a:lnSpc>
         <a:spcBef>
           <a:spcPts val="0"/>
@@ -2283,20 +2114,20 @@
         <a:buFontTx/>
         <a:buNone/>
         <a:tabLst/>
-        <a:defRPr b="0" baseline="0" cap="none" i="0" spc="0" strike="noStrike" sz="5200" u="none">
+        <a:defRPr b="0" baseline="0" cap="none" i="0" spc="0" strike="noStrike" sz="4400" u="none">
           <a:solidFill>
             <a:srgbClr val="000000"/>
           </a:solidFill>
           <a:uFillTx/>
-          <a:latin typeface="+mn-lt"/>
-          <a:ea typeface="+mn-ea"/>
-          <a:cs typeface="+mn-cs"/>
-          <a:sym typeface="Arial"/>
+          <a:latin typeface="Aptos Display"/>
+          <a:ea typeface="Aptos Display"/>
+          <a:cs typeface="Aptos Display"/>
+          <a:sym typeface="Aptos Display"/>
         </a:defRPr>
       </a:lvl2pPr>
-      <a:lvl3pPr marL="0" marR="0" indent="0" algn="ctr" defTabSz="914400" rtl="0" latinLnBrk="0">
+      <a:lvl3pPr marL="0" marR="0" indent="0" algn="l" defTabSz="914400" rtl="0" latinLnBrk="0">
         <a:lnSpc>
-          <a:spcPct val="100000"/>
+          <a:spcPct val="90000"/>
         </a:lnSpc>
         <a:spcBef>
           <a:spcPts val="0"/>
@@ -2309,20 +2140,20 @@
         <a:buFontTx/>
         <a:buNone/>
         <a:tabLst/>
-        <a:defRPr b="0" baseline="0" cap="none" i="0" spc="0" strike="noStrike" sz="5200" u="none">
+        <a:defRPr b="0" baseline="0" cap="none" i="0" spc="0" strike="noStrike" sz="4400" u="none">
           <a:solidFill>
             <a:srgbClr val="000000"/>
           </a:solidFill>
           <a:uFillTx/>
-          <a:latin typeface="+mn-lt"/>
-          <a:ea typeface="+mn-ea"/>
-          <a:cs typeface="+mn-cs"/>
-          <a:sym typeface="Arial"/>
+          <a:latin typeface="Aptos Display"/>
+          <a:ea typeface="Aptos Display"/>
+          <a:cs typeface="Aptos Display"/>
+          <a:sym typeface="Aptos Display"/>
         </a:defRPr>
       </a:lvl3pPr>
-      <a:lvl4pPr marL="0" marR="0" indent="0" algn="ctr" defTabSz="914400" rtl="0" latinLnBrk="0">
+      <a:lvl4pPr marL="0" marR="0" indent="0" algn="l" defTabSz="914400" rtl="0" latinLnBrk="0">
         <a:lnSpc>
-          <a:spcPct val="100000"/>
+          <a:spcPct val="90000"/>
         </a:lnSpc>
         <a:spcBef>
           <a:spcPts val="0"/>
@@ -2335,20 +2166,20 @@
         <a:buFontTx/>
         <a:buNone/>
         <a:tabLst/>
-        <a:defRPr b="0" baseline="0" cap="none" i="0" spc="0" strike="noStrike" sz="5200" u="none">
+        <a:defRPr b="0" baseline="0" cap="none" i="0" spc="0" strike="noStrike" sz="4400" u="none">
           <a:solidFill>
             <a:srgbClr val="000000"/>
           </a:solidFill>
           <a:uFillTx/>
-          <a:latin typeface="+mn-lt"/>
-          <a:ea typeface="+mn-ea"/>
-          <a:cs typeface="+mn-cs"/>
-          <a:sym typeface="Arial"/>
+          <a:latin typeface="Aptos Display"/>
+          <a:ea typeface="Aptos Display"/>
+          <a:cs typeface="Aptos Display"/>
+          <a:sym typeface="Aptos Display"/>
         </a:defRPr>
       </a:lvl4pPr>
-      <a:lvl5pPr marL="0" marR="0" indent="0" algn="ctr" defTabSz="914400" rtl="0" latinLnBrk="0">
+      <a:lvl5pPr marL="0" marR="0" indent="0" algn="l" defTabSz="914400" rtl="0" latinLnBrk="0">
         <a:lnSpc>
-          <a:spcPct val="100000"/>
+          <a:spcPct val="90000"/>
         </a:lnSpc>
         <a:spcBef>
           <a:spcPts val="0"/>
@@ -2361,20 +2192,20 @@
         <a:buFontTx/>
         <a:buNone/>
         <a:tabLst/>
-        <a:defRPr b="0" baseline="0" cap="none" i="0" spc="0" strike="noStrike" sz="5200" u="none">
+        <a:defRPr b="0" baseline="0" cap="none" i="0" spc="0" strike="noStrike" sz="4400" u="none">
           <a:solidFill>
             <a:srgbClr val="000000"/>
           </a:solidFill>
           <a:uFillTx/>
-          <a:latin typeface="+mn-lt"/>
-          <a:ea typeface="+mn-ea"/>
-          <a:cs typeface="+mn-cs"/>
-          <a:sym typeface="Arial"/>
+          <a:latin typeface="Aptos Display"/>
+          <a:ea typeface="Aptos Display"/>
+          <a:cs typeface="Aptos Display"/>
+          <a:sym typeface="Aptos Display"/>
         </a:defRPr>
       </a:lvl5pPr>
-      <a:lvl6pPr marL="0" marR="0" indent="0" algn="ctr" defTabSz="914400" rtl="0" latinLnBrk="0">
+      <a:lvl6pPr marL="0" marR="0" indent="0" algn="l" defTabSz="914400" rtl="0" latinLnBrk="0">
         <a:lnSpc>
-          <a:spcPct val="100000"/>
+          <a:spcPct val="90000"/>
         </a:lnSpc>
         <a:spcBef>
           <a:spcPts val="0"/>
@@ -2387,20 +2218,20 @@
         <a:buFontTx/>
         <a:buNone/>
         <a:tabLst/>
-        <a:defRPr b="0" baseline="0" cap="none" i="0" spc="0" strike="noStrike" sz="5200" u="none">
+        <a:defRPr b="0" baseline="0" cap="none" i="0" spc="0" strike="noStrike" sz="4400" u="none">
           <a:solidFill>
             <a:srgbClr val="000000"/>
           </a:solidFill>
           <a:uFillTx/>
-          <a:latin typeface="+mn-lt"/>
-          <a:ea typeface="+mn-ea"/>
-          <a:cs typeface="+mn-cs"/>
-          <a:sym typeface="Arial"/>
+          <a:latin typeface="Aptos Display"/>
+          <a:ea typeface="Aptos Display"/>
+          <a:cs typeface="Aptos Display"/>
+          <a:sym typeface="Aptos Display"/>
         </a:defRPr>
       </a:lvl6pPr>
-      <a:lvl7pPr marL="0" marR="0" indent="0" algn="ctr" defTabSz="914400" rtl="0" latinLnBrk="0">
+      <a:lvl7pPr marL="0" marR="0" indent="0" algn="l" defTabSz="914400" rtl="0" latinLnBrk="0">
         <a:lnSpc>
-          <a:spcPct val="100000"/>
+          <a:spcPct val="90000"/>
         </a:lnSpc>
         <a:spcBef>
           <a:spcPts val="0"/>
@@ -2413,20 +2244,20 @@
         <a:buFontTx/>
         <a:buNone/>
         <a:tabLst/>
-        <a:defRPr b="0" baseline="0" cap="none" i="0" spc="0" strike="noStrike" sz="5200" u="none">
+        <a:defRPr b="0" baseline="0" cap="none" i="0" spc="0" strike="noStrike" sz="4400" u="none">
           <a:solidFill>
             <a:srgbClr val="000000"/>
           </a:solidFill>
           <a:uFillTx/>
-          <a:latin typeface="+mn-lt"/>
-          <a:ea typeface="+mn-ea"/>
-          <a:cs typeface="+mn-cs"/>
-          <a:sym typeface="Arial"/>
+          <a:latin typeface="Aptos Display"/>
+          <a:ea typeface="Aptos Display"/>
+          <a:cs typeface="Aptos Display"/>
+          <a:sym typeface="Aptos Display"/>
         </a:defRPr>
       </a:lvl7pPr>
-      <a:lvl8pPr marL="0" marR="0" indent="0" algn="ctr" defTabSz="914400" rtl="0" latinLnBrk="0">
+      <a:lvl8pPr marL="0" marR="0" indent="0" algn="l" defTabSz="914400" rtl="0" latinLnBrk="0">
         <a:lnSpc>
-          <a:spcPct val="100000"/>
+          <a:spcPct val="90000"/>
         </a:lnSpc>
         <a:spcBef>
           <a:spcPts val="0"/>
@@ -2439,20 +2270,20 @@
         <a:buFontTx/>
         <a:buNone/>
         <a:tabLst/>
-        <a:defRPr b="0" baseline="0" cap="none" i="0" spc="0" strike="noStrike" sz="5200" u="none">
+        <a:defRPr b="0" baseline="0" cap="none" i="0" spc="0" strike="noStrike" sz="4400" u="none">
           <a:solidFill>
             <a:srgbClr val="000000"/>
           </a:solidFill>
           <a:uFillTx/>
-          <a:latin typeface="+mn-lt"/>
-          <a:ea typeface="+mn-ea"/>
-          <a:cs typeface="+mn-cs"/>
-          <a:sym typeface="Arial"/>
+          <a:latin typeface="Aptos Display"/>
+          <a:ea typeface="Aptos Display"/>
+          <a:cs typeface="Aptos Display"/>
+          <a:sym typeface="Aptos Display"/>
         </a:defRPr>
       </a:lvl8pPr>
-      <a:lvl9pPr marL="0" marR="0" indent="0" algn="ctr" defTabSz="914400" rtl="0" latinLnBrk="0">
+      <a:lvl9pPr marL="0" marR="0" indent="0" algn="l" defTabSz="914400" rtl="0" latinLnBrk="0">
         <a:lnSpc>
-          <a:spcPct val="100000"/>
+          <a:spcPct val="90000"/>
         </a:lnSpc>
         <a:spcBef>
           <a:spcPts val="0"/>
@@ -2465,251 +2296,251 @@
         <a:buFontTx/>
         <a:buNone/>
         <a:tabLst/>
-        <a:defRPr b="0" baseline="0" cap="none" i="0" spc="0" strike="noStrike" sz="5200" u="none">
+        <a:defRPr b="0" baseline="0" cap="none" i="0" spc="0" strike="noStrike" sz="4400" u="none">
           <a:solidFill>
             <a:srgbClr val="000000"/>
           </a:solidFill>
           <a:uFillTx/>
-          <a:latin typeface="+mn-lt"/>
-          <a:ea typeface="+mn-ea"/>
-          <a:cs typeface="+mn-cs"/>
-          <a:sym typeface="Arial"/>
+          <a:latin typeface="Aptos Display"/>
+          <a:ea typeface="Aptos Display"/>
+          <a:cs typeface="Aptos Display"/>
+          <a:sym typeface="Aptos Display"/>
         </a:defRPr>
       </a:lvl9pPr>
     </p:titleStyle>
     <p:bodyStyle>
-      <a:lvl1pPr marL="228600" marR="0" indent="-114300" algn="ctr" defTabSz="914400" rtl="0" latinLnBrk="0">
+      <a:lvl1pPr marL="228600" marR="0" indent="-228600" algn="l" defTabSz="914400" rtl="0" latinLnBrk="0">
         <a:lnSpc>
-          <a:spcPct val="100000"/>
+          <a:spcPct val="90000"/>
         </a:lnSpc>
         <a:spcBef>
-          <a:spcPts val="0"/>
+          <a:spcPts val="1000"/>
         </a:spcBef>
         <a:spcAft>
           <a:spcPts val="0"/>
         </a:spcAft>
         <a:buClrTx/>
-        <a:buSzTx/>
-        <a:buFontTx/>
-        <a:buNone/>
+        <a:buSzPct val="100000"/>
+        <a:buFont typeface="Arial"/>
+        <a:buChar char="•"/>
         <a:tabLst/>
         <a:defRPr b="0" baseline="0" cap="none" i="0" spc="0" strike="noStrike" sz="2800" u="none">
           <a:solidFill>
-            <a:srgbClr val="585858"/>
+            <a:srgbClr val="000000"/>
           </a:solidFill>
           <a:uFillTx/>
-          <a:latin typeface="+mn-lt"/>
-          <a:ea typeface="+mn-ea"/>
-          <a:cs typeface="+mn-cs"/>
-          <a:sym typeface="Arial"/>
+          <a:latin typeface="+mj-lt"/>
+          <a:ea typeface="+mj-ea"/>
+          <a:cs typeface="+mj-cs"/>
+          <a:sym typeface="Aptos"/>
         </a:defRPr>
       </a:lvl1pPr>
-      <a:lvl2pPr marL="228600" marR="0" indent="114300" algn="ctr" defTabSz="914400" rtl="0" latinLnBrk="0">
+      <a:lvl2pPr marL="723900" marR="0" indent="-266700" algn="l" defTabSz="914400" rtl="0" latinLnBrk="0">
         <a:lnSpc>
-          <a:spcPct val="100000"/>
+          <a:spcPct val="90000"/>
         </a:lnSpc>
         <a:spcBef>
-          <a:spcPts val="0"/>
+          <a:spcPts val="1000"/>
         </a:spcBef>
         <a:spcAft>
           <a:spcPts val="0"/>
         </a:spcAft>
         <a:buClrTx/>
-        <a:buSzTx/>
-        <a:buFontTx/>
-        <a:buNone/>
+        <a:buSzPct val="100000"/>
+        <a:buFont typeface="Arial"/>
+        <a:buChar char="•"/>
         <a:tabLst/>
         <a:defRPr b="0" baseline="0" cap="none" i="0" spc="0" strike="noStrike" sz="2800" u="none">
           <a:solidFill>
-            <a:srgbClr val="585858"/>
+            <a:srgbClr val="000000"/>
           </a:solidFill>
           <a:uFillTx/>
-          <a:latin typeface="+mn-lt"/>
-          <a:ea typeface="+mn-ea"/>
-          <a:cs typeface="+mn-cs"/>
-          <a:sym typeface="Arial"/>
+          <a:latin typeface="+mj-lt"/>
+          <a:ea typeface="+mj-ea"/>
+          <a:cs typeface="+mj-cs"/>
+          <a:sym typeface="Aptos"/>
         </a:defRPr>
       </a:lvl2pPr>
-      <a:lvl3pPr marL="228600" marR="0" indent="114300" algn="ctr" defTabSz="914400" rtl="0" latinLnBrk="0">
+      <a:lvl3pPr marL="1234438" marR="0" indent="-320038" algn="l" defTabSz="914400" rtl="0" latinLnBrk="0">
         <a:lnSpc>
-          <a:spcPct val="100000"/>
+          <a:spcPct val="90000"/>
         </a:lnSpc>
         <a:spcBef>
-          <a:spcPts val="0"/>
+          <a:spcPts val="1000"/>
         </a:spcBef>
         <a:spcAft>
           <a:spcPts val="0"/>
         </a:spcAft>
         <a:buClrTx/>
-        <a:buSzTx/>
-        <a:buFontTx/>
-        <a:buNone/>
+        <a:buSzPct val="100000"/>
+        <a:buFont typeface="Arial"/>
+        <a:buChar char="•"/>
         <a:tabLst/>
         <a:defRPr b="0" baseline="0" cap="none" i="0" spc="0" strike="noStrike" sz="2800" u="none">
           <a:solidFill>
-            <a:srgbClr val="585858"/>
+            <a:srgbClr val="000000"/>
           </a:solidFill>
           <a:uFillTx/>
-          <a:latin typeface="+mn-lt"/>
-          <a:ea typeface="+mn-ea"/>
-          <a:cs typeface="+mn-cs"/>
-          <a:sym typeface="Arial"/>
+          <a:latin typeface="+mj-lt"/>
+          <a:ea typeface="+mj-ea"/>
+          <a:cs typeface="+mj-cs"/>
+          <a:sym typeface="Aptos"/>
         </a:defRPr>
       </a:lvl3pPr>
-      <a:lvl4pPr marL="228600" marR="0" indent="114300" algn="ctr" defTabSz="914400" rtl="0" latinLnBrk="0">
+      <a:lvl4pPr marL="1727200" marR="0" indent="-355600" algn="l" defTabSz="914400" rtl="0" latinLnBrk="0">
         <a:lnSpc>
-          <a:spcPct val="100000"/>
+          <a:spcPct val="90000"/>
         </a:lnSpc>
         <a:spcBef>
-          <a:spcPts val="0"/>
+          <a:spcPts val="1000"/>
         </a:spcBef>
         <a:spcAft>
           <a:spcPts val="0"/>
         </a:spcAft>
         <a:buClrTx/>
-        <a:buSzTx/>
-        <a:buFontTx/>
-        <a:buNone/>
+        <a:buSzPct val="100000"/>
+        <a:buFont typeface="Arial"/>
+        <a:buChar char="•"/>
         <a:tabLst/>
         <a:defRPr b="0" baseline="0" cap="none" i="0" spc="0" strike="noStrike" sz="2800" u="none">
           <a:solidFill>
-            <a:srgbClr val="585858"/>
+            <a:srgbClr val="000000"/>
           </a:solidFill>
           <a:uFillTx/>
-          <a:latin typeface="+mn-lt"/>
-          <a:ea typeface="+mn-ea"/>
-          <a:cs typeface="+mn-cs"/>
-          <a:sym typeface="Arial"/>
+          <a:latin typeface="+mj-lt"/>
+          <a:ea typeface="+mj-ea"/>
+          <a:cs typeface="+mj-cs"/>
+          <a:sym typeface="Aptos"/>
         </a:defRPr>
       </a:lvl4pPr>
-      <a:lvl5pPr marL="228600" marR="0" indent="114300" algn="ctr" defTabSz="914400" rtl="0" latinLnBrk="0">
+      <a:lvl5pPr marL="2184400" marR="0" indent="-355600" algn="l" defTabSz="914400" rtl="0" latinLnBrk="0">
         <a:lnSpc>
-          <a:spcPct val="100000"/>
+          <a:spcPct val="90000"/>
         </a:lnSpc>
         <a:spcBef>
-          <a:spcPts val="0"/>
+          <a:spcPts val="1000"/>
         </a:spcBef>
         <a:spcAft>
           <a:spcPts val="0"/>
         </a:spcAft>
         <a:buClrTx/>
-        <a:buSzTx/>
-        <a:buFontTx/>
-        <a:buNone/>
+        <a:buSzPct val="100000"/>
+        <a:buFont typeface="Arial"/>
+        <a:buChar char="•"/>
         <a:tabLst/>
         <a:defRPr b="0" baseline="0" cap="none" i="0" spc="0" strike="noStrike" sz="2800" u="none">
           <a:solidFill>
-            <a:srgbClr val="585858"/>
+            <a:srgbClr val="000000"/>
           </a:solidFill>
           <a:uFillTx/>
-          <a:latin typeface="+mn-lt"/>
-          <a:ea typeface="+mn-ea"/>
-          <a:cs typeface="+mn-cs"/>
-          <a:sym typeface="Arial"/>
+          <a:latin typeface="+mj-lt"/>
+          <a:ea typeface="+mj-ea"/>
+          <a:cs typeface="+mj-cs"/>
+          <a:sym typeface="Aptos"/>
         </a:defRPr>
       </a:lvl5pPr>
-      <a:lvl6pPr marL="228600" marR="0" indent="114300" algn="ctr" defTabSz="914400" rtl="0" latinLnBrk="0">
+      <a:lvl6pPr marL="2641600" marR="0" indent="-355600" algn="l" defTabSz="914400" rtl="0" latinLnBrk="0">
         <a:lnSpc>
-          <a:spcPct val="100000"/>
+          <a:spcPct val="90000"/>
         </a:lnSpc>
         <a:spcBef>
-          <a:spcPts val="0"/>
+          <a:spcPts val="1000"/>
         </a:spcBef>
         <a:spcAft>
           <a:spcPts val="0"/>
         </a:spcAft>
         <a:buClrTx/>
-        <a:buSzTx/>
-        <a:buFontTx/>
-        <a:buNone/>
+        <a:buSzPct val="100000"/>
+        <a:buFont typeface="Arial"/>
+        <a:buChar char="•"/>
         <a:tabLst/>
         <a:defRPr b="0" baseline="0" cap="none" i="0" spc="0" strike="noStrike" sz="2800" u="none">
           <a:solidFill>
-            <a:srgbClr val="585858"/>
+            <a:srgbClr val="000000"/>
           </a:solidFill>
           <a:uFillTx/>
-          <a:latin typeface="+mn-lt"/>
-          <a:ea typeface="+mn-ea"/>
-          <a:cs typeface="+mn-cs"/>
-          <a:sym typeface="Arial"/>
+          <a:latin typeface="+mj-lt"/>
+          <a:ea typeface="+mj-ea"/>
+          <a:cs typeface="+mj-cs"/>
+          <a:sym typeface="Aptos"/>
         </a:defRPr>
       </a:lvl6pPr>
-      <a:lvl7pPr marL="228600" marR="0" indent="114300" algn="ctr" defTabSz="914400" rtl="0" latinLnBrk="0">
+      <a:lvl7pPr marL="3098800" marR="0" indent="-355600" algn="l" defTabSz="914400" rtl="0" latinLnBrk="0">
         <a:lnSpc>
-          <a:spcPct val="100000"/>
+          <a:spcPct val="90000"/>
         </a:lnSpc>
         <a:spcBef>
-          <a:spcPts val="0"/>
+          <a:spcPts val="1000"/>
         </a:spcBef>
         <a:spcAft>
           <a:spcPts val="0"/>
         </a:spcAft>
         <a:buClrTx/>
-        <a:buSzTx/>
-        <a:buFontTx/>
-        <a:buNone/>
+        <a:buSzPct val="100000"/>
+        <a:buFont typeface="Arial"/>
+        <a:buChar char="•"/>
         <a:tabLst/>
         <a:defRPr b="0" baseline="0" cap="none" i="0" spc="0" strike="noStrike" sz="2800" u="none">
           <a:solidFill>
-            <a:srgbClr val="585858"/>
+            <a:srgbClr val="000000"/>
           </a:solidFill>
           <a:uFillTx/>
-          <a:latin typeface="+mn-lt"/>
-          <a:ea typeface="+mn-ea"/>
-          <a:cs typeface="+mn-cs"/>
-          <a:sym typeface="Arial"/>
+          <a:latin typeface="+mj-lt"/>
+          <a:ea typeface="+mj-ea"/>
+          <a:cs typeface="+mj-cs"/>
+          <a:sym typeface="Aptos"/>
         </a:defRPr>
       </a:lvl7pPr>
-      <a:lvl8pPr marL="228600" marR="0" indent="114300" algn="ctr" defTabSz="914400" rtl="0" latinLnBrk="0">
+      <a:lvl8pPr marL="3556000" marR="0" indent="-355600" algn="l" defTabSz="914400" rtl="0" latinLnBrk="0">
         <a:lnSpc>
-          <a:spcPct val="100000"/>
+          <a:spcPct val="90000"/>
         </a:lnSpc>
         <a:spcBef>
-          <a:spcPts val="0"/>
+          <a:spcPts val="1000"/>
         </a:spcBef>
         <a:spcAft>
           <a:spcPts val="0"/>
         </a:spcAft>
         <a:buClrTx/>
-        <a:buSzTx/>
-        <a:buFontTx/>
-        <a:buNone/>
+        <a:buSzPct val="100000"/>
+        <a:buFont typeface="Arial"/>
+        <a:buChar char="•"/>
         <a:tabLst/>
         <a:defRPr b="0" baseline="0" cap="none" i="0" spc="0" strike="noStrike" sz="2800" u="none">
           <a:solidFill>
-            <a:srgbClr val="585858"/>
+            <a:srgbClr val="000000"/>
           </a:solidFill>
           <a:uFillTx/>
-          <a:latin typeface="+mn-lt"/>
-          <a:ea typeface="+mn-ea"/>
-          <a:cs typeface="+mn-cs"/>
-          <a:sym typeface="Arial"/>
+          <a:latin typeface="+mj-lt"/>
+          <a:ea typeface="+mj-ea"/>
+          <a:cs typeface="+mj-cs"/>
+          <a:sym typeface="Aptos"/>
         </a:defRPr>
       </a:lvl8pPr>
-      <a:lvl9pPr marL="228600" marR="0" indent="114300" algn="ctr" defTabSz="914400" rtl="0" latinLnBrk="0">
+      <a:lvl9pPr marL="4013200" marR="0" indent="-355600" algn="l" defTabSz="914400" rtl="0" latinLnBrk="0">
         <a:lnSpc>
-          <a:spcPct val="100000"/>
+          <a:spcPct val="90000"/>
         </a:lnSpc>
         <a:spcBef>
-          <a:spcPts val="0"/>
+          <a:spcPts val="1000"/>
         </a:spcBef>
         <a:spcAft>
           <a:spcPts val="0"/>
         </a:spcAft>
         <a:buClrTx/>
-        <a:buSzTx/>
-        <a:buFontTx/>
-        <a:buNone/>
+        <a:buSzPct val="100000"/>
+        <a:buFont typeface="Arial"/>
+        <a:buChar char="•"/>
         <a:tabLst/>
         <a:defRPr b="0" baseline="0" cap="none" i="0" spc="0" strike="noStrike" sz="2800" u="none">
           <a:solidFill>
-            <a:srgbClr val="585858"/>
+            <a:srgbClr val="000000"/>
           </a:solidFill>
           <a:uFillTx/>
-          <a:latin typeface="+mn-lt"/>
-          <a:ea typeface="+mn-ea"/>
-          <a:cs typeface="+mn-cs"/>
-          <a:sym typeface="Arial"/>
+          <a:latin typeface="+mj-lt"/>
+          <a:ea typeface="+mj-ea"/>
+          <a:cs typeface="+mj-cs"/>
+          <a:sym typeface="Aptos"/>
         </a:defRPr>
       </a:lvl9pPr>
     </p:bodyStyle>
@@ -2729,7 +2560,7 @@
         <a:buFontTx/>
         <a:buNone/>
         <a:tabLst/>
-        <a:defRPr b="0" baseline="0" cap="none" i="0" spc="0" strike="noStrike" sz="1000" u="none">
+        <a:defRPr b="0" baseline="0" cap="none" i="0" spc="0" strike="noStrike" sz="1200" u="none">
           <a:solidFill>
             <a:schemeClr val="tx1"/>
           </a:solidFill>
@@ -2737,7 +2568,7 @@
           <a:latin typeface="+mn-lt"/>
           <a:ea typeface="+mn-ea"/>
           <a:cs typeface="+mn-cs"/>
-          <a:sym typeface="Arial"/>
+          <a:sym typeface="Aptos"/>
         </a:defRPr>
       </a:lvl1pPr>
       <a:lvl2pPr marL="0" marR="0" indent="0" algn="r" defTabSz="914400" rtl="0" latinLnBrk="0">
@@ -2755,7 +2586,7 @@
         <a:buFontTx/>
         <a:buNone/>
         <a:tabLst/>
-        <a:defRPr b="0" baseline="0" cap="none" i="0" spc="0" strike="noStrike" sz="1000" u="none">
+        <a:defRPr b="0" baseline="0" cap="none" i="0" spc="0" strike="noStrike" sz="1200" u="none">
           <a:solidFill>
             <a:schemeClr val="tx1"/>
           </a:solidFill>
@@ -2763,7 +2594,7 @@
           <a:latin typeface="+mn-lt"/>
           <a:ea typeface="+mn-ea"/>
           <a:cs typeface="+mn-cs"/>
-          <a:sym typeface="Arial"/>
+          <a:sym typeface="Aptos"/>
         </a:defRPr>
       </a:lvl2pPr>
       <a:lvl3pPr marL="0" marR="0" indent="0" algn="r" defTabSz="914400" rtl="0" latinLnBrk="0">
@@ -2781,7 +2612,7 @@
         <a:buFontTx/>
         <a:buNone/>
         <a:tabLst/>
-        <a:defRPr b="0" baseline="0" cap="none" i="0" spc="0" strike="noStrike" sz="1000" u="none">
+        <a:defRPr b="0" baseline="0" cap="none" i="0" spc="0" strike="noStrike" sz="1200" u="none">
           <a:solidFill>
             <a:schemeClr val="tx1"/>
           </a:solidFill>
@@ -2789,7 +2620,7 @@
           <a:latin typeface="+mn-lt"/>
           <a:ea typeface="+mn-ea"/>
           <a:cs typeface="+mn-cs"/>
-          <a:sym typeface="Arial"/>
+          <a:sym typeface="Aptos"/>
         </a:defRPr>
       </a:lvl3pPr>
       <a:lvl4pPr marL="0" marR="0" indent="0" algn="r" defTabSz="914400" rtl="0" latinLnBrk="0">
@@ -2807,7 +2638,7 @@
         <a:buFontTx/>
         <a:buNone/>
         <a:tabLst/>
-        <a:defRPr b="0" baseline="0" cap="none" i="0" spc="0" strike="noStrike" sz="1000" u="none">
+        <a:defRPr b="0" baseline="0" cap="none" i="0" spc="0" strike="noStrike" sz="1200" u="none">
           <a:solidFill>
             <a:schemeClr val="tx1"/>
           </a:solidFill>
@@ -2815,7 +2646,7 @@
           <a:latin typeface="+mn-lt"/>
           <a:ea typeface="+mn-ea"/>
           <a:cs typeface="+mn-cs"/>
-          <a:sym typeface="Arial"/>
+          <a:sym typeface="Aptos"/>
         </a:defRPr>
       </a:lvl4pPr>
       <a:lvl5pPr marL="0" marR="0" indent="0" algn="r" defTabSz="914400" rtl="0" latinLnBrk="0">
@@ -2833,7 +2664,7 @@
         <a:buFontTx/>
         <a:buNone/>
         <a:tabLst/>
-        <a:defRPr b="0" baseline="0" cap="none" i="0" spc="0" strike="noStrike" sz="1000" u="none">
+        <a:defRPr b="0" baseline="0" cap="none" i="0" spc="0" strike="noStrike" sz="1200" u="none">
           <a:solidFill>
             <a:schemeClr val="tx1"/>
           </a:solidFill>
@@ -2841,7 +2672,7 @@
           <a:latin typeface="+mn-lt"/>
           <a:ea typeface="+mn-ea"/>
           <a:cs typeface="+mn-cs"/>
-          <a:sym typeface="Arial"/>
+          <a:sym typeface="Aptos"/>
         </a:defRPr>
       </a:lvl5pPr>
       <a:lvl6pPr marL="0" marR="0" indent="0" algn="r" defTabSz="914400" rtl="0" latinLnBrk="0">
@@ -2859,7 +2690,7 @@
         <a:buFontTx/>
         <a:buNone/>
         <a:tabLst/>
-        <a:defRPr b="0" baseline="0" cap="none" i="0" spc="0" strike="noStrike" sz="1000" u="none">
+        <a:defRPr b="0" baseline="0" cap="none" i="0" spc="0" strike="noStrike" sz="1200" u="none">
           <a:solidFill>
             <a:schemeClr val="tx1"/>
           </a:solidFill>
@@ -2867,7 +2698,7 @@
           <a:latin typeface="+mn-lt"/>
           <a:ea typeface="+mn-ea"/>
           <a:cs typeface="+mn-cs"/>
-          <a:sym typeface="Arial"/>
+          <a:sym typeface="Aptos"/>
         </a:defRPr>
       </a:lvl6pPr>
       <a:lvl7pPr marL="0" marR="0" indent="0" algn="r" defTabSz="914400" rtl="0" latinLnBrk="0">
@@ -2885,7 +2716,7 @@
         <a:buFontTx/>
         <a:buNone/>
         <a:tabLst/>
-        <a:defRPr b="0" baseline="0" cap="none" i="0" spc="0" strike="noStrike" sz="1000" u="none">
+        <a:defRPr b="0" baseline="0" cap="none" i="0" spc="0" strike="noStrike" sz="1200" u="none">
           <a:solidFill>
             <a:schemeClr val="tx1"/>
           </a:solidFill>
@@ -2893,7 +2724,7 @@
           <a:latin typeface="+mn-lt"/>
           <a:ea typeface="+mn-ea"/>
           <a:cs typeface="+mn-cs"/>
-          <a:sym typeface="Arial"/>
+          <a:sym typeface="Aptos"/>
         </a:defRPr>
       </a:lvl7pPr>
       <a:lvl8pPr marL="0" marR="0" indent="0" algn="r" defTabSz="914400" rtl="0" latinLnBrk="0">
@@ -2911,7 +2742,7 @@
         <a:buFontTx/>
         <a:buNone/>
         <a:tabLst/>
-        <a:defRPr b="0" baseline="0" cap="none" i="0" spc="0" strike="noStrike" sz="1000" u="none">
+        <a:defRPr b="0" baseline="0" cap="none" i="0" spc="0" strike="noStrike" sz="1200" u="none">
           <a:solidFill>
             <a:schemeClr val="tx1"/>
           </a:solidFill>
@@ -2919,7 +2750,7 @@
           <a:latin typeface="+mn-lt"/>
           <a:ea typeface="+mn-ea"/>
           <a:cs typeface="+mn-cs"/>
-          <a:sym typeface="Arial"/>
+          <a:sym typeface="Aptos"/>
         </a:defRPr>
       </a:lvl8pPr>
       <a:lvl9pPr marL="0" marR="0" indent="0" algn="r" defTabSz="914400" rtl="0" latinLnBrk="0">
@@ -2937,7 +2768,7 @@
         <a:buFontTx/>
         <a:buNone/>
         <a:tabLst/>
-        <a:defRPr b="0" baseline="0" cap="none" i="0" spc="0" strike="noStrike" sz="1000" u="none">
+        <a:defRPr b="0" baseline="0" cap="none" i="0" spc="0" strike="noStrike" sz="1200" u="none">
           <a:solidFill>
             <a:schemeClr val="tx1"/>
           </a:solidFill>
@@ -2945,7 +2776,7 @@
           <a:latin typeface="+mn-lt"/>
           <a:ea typeface="+mn-ea"/>
           <a:cs typeface="+mn-cs"/>
-          <a:sym typeface="Arial"/>
+          <a:sym typeface="Aptos"/>
         </a:defRPr>
       </a:lvl9pPr>
     </p:otherStyle>
@@ -2956,13 +2787,6 @@
 <file path=ppt/slides/slide1.xml><?xml version="1.0" encoding="utf-8"?>
 <p:sld xmlns:a="http://schemas.openxmlformats.org/drawingml/2006/main" xmlns:r="http://schemas.openxmlformats.org/officeDocument/2006/relationships" xmlns:p="http://schemas.openxmlformats.org/presentationml/2006/main" xmlns:m="http://schemas.openxmlformats.org/officeDocument/2006/math" xmlns:a14="http://schemas.microsoft.com/office/drawing/2010/main" showMasterSp="1" showMasterPhAnim="1">
   <p:cSld>
-    <p:bg>
-      <p:bgPr>
-        <a:solidFill>
-          <a:srgbClr val="EDE4A6"/>
-        </a:solidFill>
-      </p:bgPr>
-    </p:bg>
     <p:spTree>
       <p:nvGrpSpPr>
         <p:cNvPr id="1" name=""/>
@@ -2977,16 +2801,76 @@
           <a:chExt cx="0" cy="0"/>
         </a:xfrm>
       </p:grpSpPr>
+      <p:pic>
+        <p:nvPicPr>
+          <p:cNvPr id="104" name="Picture Placeholder 6" descr="Picture Placeholder 6"/>
+          <p:cNvPicPr>
+            <a:picLocks noChangeAspect="1"/>
+          </p:cNvPicPr>
+          <p:nvPr>
+            <p:ph type="pic" idx="21"/>
+          </p:nvPr>
+        </p:nvPicPr>
+        <p:blipFill>
+          <a:blip r:embed="rId2">
+            <a:extLst/>
+          </a:blip>
+          <a:stretch>
+            <a:fillRect/>
+          </a:stretch>
+        </p:blipFill>
+        <p:spPr>
+          <a:prstGeom prst="rect">
+            <a:avLst/>
+          </a:prstGeom>
+        </p:spPr>
+      </p:pic>
       <p:sp>
         <p:nvSpPr>
-          <p:cNvPr id="111" name="Google Shape;57;p13"/>
+          <p:cNvPr id="105" name="Google Shape;67;p14"/>
+          <p:cNvSpPr/>
+          <p:nvPr/>
+        </p:nvSpPr>
+        <p:spPr>
+          <a:xfrm>
+            <a:off x="279755" y="1090595"/>
+            <a:ext cx="11632490" cy="5525332"/>
+          </a:xfrm>
+          <a:prstGeom prst="rect">
+            <a:avLst/>
+          </a:prstGeom>
+          <a:solidFill>
+            <a:srgbClr val="FFFFFF"/>
+          </a:solidFill>
+          <a:ln w="12700">
+            <a:miter lim="400000"/>
+          </a:ln>
+        </p:spPr>
+        <p:txBody>
+          <a:bodyPr lIns="45718" tIns="45718" rIns="45718" bIns="45718" anchor="ctr"/>
+          <a:lstStyle/>
+          <a:p>
+            <a:pPr>
+              <a:defRPr>
+                <a:latin typeface="Arial"/>
+                <a:ea typeface="Arial"/>
+                <a:cs typeface="Arial"/>
+                <a:sym typeface="Arial"/>
+              </a:defRPr>
+            </a:pPr>
+          </a:p>
+        </p:txBody>
+      </p:sp>
+      <p:sp>
+        <p:nvSpPr>
+          <p:cNvPr id="106" name="Google Shape;68;p14"/>
           <p:cNvSpPr txBox="1"/>
           <p:nvPr/>
         </p:nvSpPr>
         <p:spPr>
           <a:xfrm>
-            <a:off x="605400" y="4735343"/>
-            <a:ext cx="7018800" cy="640049"/>
+            <a:off x="713450" y="1374203"/>
+            <a:ext cx="10850068" cy="683548"/>
           </a:xfrm>
           <a:prstGeom prst="rect">
             <a:avLst/>
@@ -3001,40 +2885,37 @@
           </a:extLst>
         </p:spPr>
         <p:txBody>
-          <a:bodyPr lIns="91423" tIns="91423" rIns="91423" bIns="91423" anchor="ctr">
+          <a:bodyPr lIns="45699" tIns="45699" rIns="45699" bIns="45699">
             <a:spAutoFit/>
           </a:bodyPr>
           <a:lstStyle>
             <a:lvl1pPr algn="ctr">
-              <a:lnSpc>
-                <a:spcPct val="115000"/>
-              </a:lnSpc>
-              <a:defRPr b="1" sz="2600">
-                <a:latin typeface="Avenir Next Regular"/>
-                <a:ea typeface="Avenir Next Regular"/>
-                <a:cs typeface="Avenir Next Regular"/>
-                <a:sym typeface="Avenir Next Regular"/>
+              <a:defRPr sz="4200">
+                <a:latin typeface="Arial"/>
+                <a:ea typeface="Arial"/>
+                <a:cs typeface="Arial"/>
+                <a:sym typeface="Arial"/>
               </a:defRPr>
             </a:lvl1pPr>
           </a:lstStyle>
           <a:p>
             <a:pPr/>
             <a:r>
-              <a:t>Job Opening for</a:t>
+              <a:t>{{COMPANY_NAME}}</a:t>
             </a:r>
           </a:p>
         </p:txBody>
       </p:sp>
       <p:sp>
         <p:nvSpPr>
-          <p:cNvPr id="112" name="Google Shape;58;p13"/>
+          <p:cNvPr id="107" name="Google Shape;69;p14"/>
           <p:cNvSpPr txBox="1"/>
           <p:nvPr/>
         </p:nvSpPr>
         <p:spPr>
           <a:xfrm>
-            <a:off x="468600" y="5525495"/>
-            <a:ext cx="7292400" cy="601949"/>
+            <a:off x="280152" y="2233672"/>
+            <a:ext cx="11631696" cy="313352"/>
           </a:xfrm>
           <a:prstGeom prst="rect">
             <a:avLst/>
@@ -3049,40 +2930,37 @@
           </a:extLst>
         </p:spPr>
         <p:txBody>
-          <a:bodyPr lIns="91423" tIns="91423" rIns="91423" bIns="91423" anchor="ctr">
+          <a:bodyPr lIns="45699" tIns="45699" rIns="45699" bIns="45699">
             <a:spAutoFit/>
           </a:bodyPr>
           <a:lstStyle>
             <a:lvl1pPr algn="ctr">
-              <a:lnSpc>
-                <a:spcPct val="115000"/>
-              </a:lnSpc>
-              <a:defRPr sz="2400">
-                <a:latin typeface="Avenir Next Regular"/>
-                <a:ea typeface="Avenir Next Regular"/>
-                <a:cs typeface="Avenir Next Regular"/>
-                <a:sym typeface="Avenir Next Regular"/>
+              <a:defRPr sz="1600">
+                <a:latin typeface="Arial"/>
+                <a:ea typeface="Arial"/>
+                <a:cs typeface="Arial"/>
+                <a:sym typeface="Arial"/>
               </a:defRPr>
             </a:lvl1pPr>
           </a:lstStyle>
           <a:p>
             <a:pPr/>
             <a:r>
-              <a:t>{{POSITION}}</a:t>
+              <a:t>Job Opening for</a:t>
             </a:r>
           </a:p>
         </p:txBody>
       </p:sp>
       <p:sp>
         <p:nvSpPr>
-          <p:cNvPr id="113" name="Google Shape;59;p13"/>
+          <p:cNvPr id="108" name="Google Shape;70;p14"/>
           <p:cNvSpPr txBox="1"/>
           <p:nvPr/>
         </p:nvSpPr>
         <p:spPr>
           <a:xfrm>
-            <a:off x="605400" y="6600174"/>
-            <a:ext cx="7018800" cy="640049"/>
+            <a:off x="713374" y="2583400"/>
+            <a:ext cx="10765251" cy="437027"/>
           </a:xfrm>
           <a:prstGeom prst="rect">
             <a:avLst/>
@@ -3097,40 +2975,37 @@
           </a:extLst>
         </p:spPr>
         <p:txBody>
-          <a:bodyPr lIns="91423" tIns="91423" rIns="91423" bIns="91423" anchor="ctr">
+          <a:bodyPr lIns="45699" tIns="45699" rIns="45699" bIns="45699">
             <a:spAutoFit/>
           </a:bodyPr>
           <a:lstStyle>
             <a:lvl1pPr algn="ctr">
-              <a:lnSpc>
-                <a:spcPct val="115000"/>
-              </a:lnSpc>
-              <a:defRPr b="1" sz="2600">
-                <a:latin typeface="Avenir Next Regular"/>
-                <a:ea typeface="Avenir Next Regular"/>
-                <a:cs typeface="Avenir Next Regular"/>
-                <a:sym typeface="Avenir Next Regular"/>
+              <a:defRPr sz="2400">
+                <a:latin typeface="Arial"/>
+                <a:ea typeface="Arial"/>
+                <a:cs typeface="Arial"/>
+                <a:sym typeface="Arial"/>
               </a:defRPr>
             </a:lvl1pPr>
           </a:lstStyle>
           <a:p>
             <a:pPr/>
             <a:r>
-              <a:t>Experience Required</a:t>
+              <a:t>{{POSITION}}</a:t>
             </a:r>
           </a:p>
         </p:txBody>
       </p:sp>
       <p:sp>
         <p:nvSpPr>
-          <p:cNvPr id="114" name="Google Shape;60;p13"/>
+          <p:cNvPr id="109" name="Google Shape;71;p14"/>
           <p:cNvSpPr txBox="1"/>
           <p:nvPr/>
         </p:nvSpPr>
         <p:spPr>
           <a:xfrm>
-            <a:off x="468600" y="7395688"/>
-            <a:ext cx="7292400" cy="601949"/>
+            <a:off x="6093137" y="4763375"/>
+            <a:ext cx="5578752" cy="313351"/>
           </a:xfrm>
           <a:prstGeom prst="rect">
             <a:avLst/>
@@ -3145,40 +3020,37 @@
           </a:extLst>
         </p:spPr>
         <p:txBody>
-          <a:bodyPr lIns="91423" tIns="91423" rIns="91423" bIns="91423" anchor="ctr">
+          <a:bodyPr lIns="45699" tIns="45699" rIns="45699" bIns="45699">
             <a:spAutoFit/>
           </a:bodyPr>
           <a:lstStyle>
             <a:lvl1pPr algn="ctr">
-              <a:lnSpc>
-                <a:spcPct val="115000"/>
-              </a:lnSpc>
-              <a:defRPr sz="2400">
-                <a:latin typeface="Avenir Next Regular"/>
-                <a:ea typeface="Avenir Next Regular"/>
-                <a:cs typeface="Avenir Next Regular"/>
-                <a:sym typeface="Avenir Next Regular"/>
+              <a:defRPr sz="1600">
+                <a:latin typeface="Arial"/>
+                <a:ea typeface="Arial"/>
+                <a:cs typeface="Arial"/>
+                <a:sym typeface="Arial"/>
               </a:defRPr>
             </a:lvl1pPr>
           </a:lstStyle>
           <a:p>
             <a:pPr/>
             <a:r>
-              <a:t>{{EXPERIENCE}}</a:t>
+              <a:t>Job Type</a:t>
             </a:r>
           </a:p>
         </p:txBody>
       </p:sp>
       <p:sp>
         <p:nvSpPr>
-          <p:cNvPr id="115" name="Google Shape;61;p13"/>
+          <p:cNvPr id="110" name="Google Shape;72;p14"/>
           <p:cNvSpPr txBox="1"/>
           <p:nvPr/>
         </p:nvSpPr>
         <p:spPr>
           <a:xfrm>
-            <a:off x="605400" y="8422246"/>
-            <a:ext cx="7018800" cy="640049"/>
+            <a:off x="6215512" y="5073679"/>
+            <a:ext cx="5334003" cy="375189"/>
           </a:xfrm>
           <a:prstGeom prst="rect">
             <a:avLst/>
@@ -3193,40 +3065,37 @@
           </a:extLst>
         </p:spPr>
         <p:txBody>
-          <a:bodyPr lIns="91423" tIns="91423" rIns="91423" bIns="91423" anchor="ctr">
+          <a:bodyPr lIns="45699" tIns="45699" rIns="45699" bIns="45699">
             <a:spAutoFit/>
           </a:bodyPr>
           <a:lstStyle>
             <a:lvl1pPr algn="ctr">
-              <a:lnSpc>
-                <a:spcPct val="115000"/>
-              </a:lnSpc>
-              <a:defRPr b="1" sz="2600">
-                <a:latin typeface="Avenir Next Regular"/>
-                <a:ea typeface="Avenir Next Regular"/>
-                <a:cs typeface="Avenir Next Regular"/>
-                <a:sym typeface="Avenir Next Regular"/>
+              <a:defRPr sz="2000">
+                <a:latin typeface="Arial"/>
+                <a:ea typeface="Arial"/>
+                <a:cs typeface="Arial"/>
+                <a:sym typeface="Arial"/>
               </a:defRPr>
             </a:lvl1pPr>
           </a:lstStyle>
           <a:p>
             <a:pPr/>
             <a:r>
-              <a:t>Skills Required</a:t>
+              <a:t>{{JOB_TYPE}}</a:t>
             </a:r>
           </a:p>
         </p:txBody>
       </p:sp>
       <p:sp>
         <p:nvSpPr>
-          <p:cNvPr id="116" name="Google Shape;62;p13"/>
+          <p:cNvPr id="111" name="Google Shape;73;p14"/>
           <p:cNvSpPr txBox="1"/>
           <p:nvPr/>
         </p:nvSpPr>
         <p:spPr>
           <a:xfrm>
-            <a:off x="468600" y="9215009"/>
-            <a:ext cx="7292400" cy="601949"/>
+            <a:off x="2053823" y="5692961"/>
+            <a:ext cx="8169321" cy="313351"/>
           </a:xfrm>
           <a:prstGeom prst="rect">
             <a:avLst/>
@@ -3241,40 +3110,37 @@
           </a:extLst>
         </p:spPr>
         <p:txBody>
-          <a:bodyPr lIns="91423" tIns="91423" rIns="91423" bIns="91423" anchor="ctr">
+          <a:bodyPr lIns="45699" tIns="45699" rIns="45699" bIns="45699">
             <a:spAutoFit/>
           </a:bodyPr>
           <a:lstStyle>
             <a:lvl1pPr algn="ctr">
-              <a:lnSpc>
-                <a:spcPct val="115000"/>
-              </a:lnSpc>
-              <a:defRPr sz="2400">
-                <a:latin typeface="Avenir Next Regular"/>
-                <a:ea typeface="Avenir Next Regular"/>
-                <a:cs typeface="Avenir Next Regular"/>
-                <a:sym typeface="Avenir Next Regular"/>
+              <a:defRPr sz="1600">
+                <a:latin typeface="Arial"/>
+                <a:ea typeface="Arial"/>
+                <a:cs typeface="Arial"/>
+                <a:sym typeface="Arial"/>
               </a:defRPr>
             </a:lvl1pPr>
           </a:lstStyle>
           <a:p>
             <a:pPr/>
             <a:r>
-              <a:t>{{SKILLS}}</a:t>
+              <a:t>To Apply Visit: {{LINK}}</a:t>
             </a:r>
           </a:p>
         </p:txBody>
       </p:sp>
       <p:sp>
         <p:nvSpPr>
-          <p:cNvPr id="117" name="Google Shape;63;p13"/>
+          <p:cNvPr id="112" name="Google Shape;74;p14"/>
           <p:cNvSpPr txBox="1"/>
           <p:nvPr/>
         </p:nvSpPr>
         <p:spPr>
           <a:xfrm>
-            <a:off x="605400" y="10229377"/>
-            <a:ext cx="7018800" cy="640049"/>
+            <a:off x="660521" y="3404220"/>
+            <a:ext cx="5297935" cy="313351"/>
           </a:xfrm>
           <a:prstGeom prst="rect">
             <a:avLst/>
@@ -3289,40 +3155,37 @@
           </a:extLst>
         </p:spPr>
         <p:txBody>
-          <a:bodyPr lIns="91423" tIns="91423" rIns="91423" bIns="91423" anchor="ctr">
+          <a:bodyPr lIns="45699" tIns="45699" rIns="45699" bIns="45699">
             <a:spAutoFit/>
           </a:bodyPr>
           <a:lstStyle>
             <a:lvl1pPr algn="ctr">
-              <a:lnSpc>
-                <a:spcPct val="115000"/>
-              </a:lnSpc>
-              <a:defRPr b="1" sz="2600">
-                <a:latin typeface="Avenir Next Regular"/>
-                <a:ea typeface="Avenir Next Regular"/>
-                <a:cs typeface="Avenir Next Regular"/>
-                <a:sym typeface="Avenir Next Regular"/>
+              <a:defRPr sz="1600">
+                <a:latin typeface="Arial"/>
+                <a:ea typeface="Arial"/>
+                <a:cs typeface="Arial"/>
+                <a:sym typeface="Arial"/>
               </a:defRPr>
             </a:lvl1pPr>
           </a:lstStyle>
           <a:p>
             <a:pPr/>
             <a:r>
-              <a:t>Location</a:t>
+              <a:t>Experience Required</a:t>
             </a:r>
           </a:p>
         </p:txBody>
       </p:sp>
       <p:sp>
         <p:nvSpPr>
-          <p:cNvPr id="118" name="Google Shape;64;p13"/>
+          <p:cNvPr id="113" name="Google Shape;75;p14"/>
           <p:cNvSpPr txBox="1"/>
           <p:nvPr/>
         </p:nvSpPr>
         <p:spPr>
           <a:xfrm>
-            <a:off x="468650" y="11019638"/>
-            <a:ext cx="7292400" cy="601949"/>
+            <a:off x="642486" y="3710132"/>
+            <a:ext cx="5334005" cy="375189"/>
           </a:xfrm>
           <a:prstGeom prst="rect">
             <a:avLst/>
@@ -3337,40 +3200,37 @@
           </a:extLst>
         </p:spPr>
         <p:txBody>
-          <a:bodyPr lIns="91423" tIns="91423" rIns="91423" bIns="91423" anchor="ctr">
+          <a:bodyPr lIns="45699" tIns="45699" rIns="45699" bIns="45699">
             <a:spAutoFit/>
           </a:bodyPr>
           <a:lstStyle>
             <a:lvl1pPr algn="ctr">
-              <a:lnSpc>
-                <a:spcPct val="115000"/>
-              </a:lnSpc>
-              <a:defRPr sz="2400">
-                <a:latin typeface="Avenir Next Regular"/>
-                <a:ea typeface="Avenir Next Regular"/>
-                <a:cs typeface="Avenir Next Regular"/>
-                <a:sym typeface="Avenir Next Regular"/>
+              <a:defRPr sz="2000">
+                <a:latin typeface="Arial"/>
+                <a:ea typeface="Arial"/>
+                <a:cs typeface="Arial"/>
+                <a:sym typeface="Arial"/>
               </a:defRPr>
             </a:lvl1pPr>
           </a:lstStyle>
           <a:p>
             <a:pPr/>
             <a:r>
-              <a:t>{{LOCATION}}</a:t>
+              <a:t>{{EXPERIENCE}}</a:t>
             </a:r>
           </a:p>
         </p:txBody>
       </p:sp>
       <p:sp>
         <p:nvSpPr>
-          <p:cNvPr id="119" name="Google Shape;65;p13"/>
+          <p:cNvPr id="114" name="Google Shape;76;p14"/>
           <p:cNvSpPr txBox="1"/>
           <p:nvPr/>
         </p:nvSpPr>
         <p:spPr>
           <a:xfrm>
-            <a:off x="605450" y="12093698"/>
-            <a:ext cx="7018800" cy="640049"/>
+            <a:off x="6048976" y="3404220"/>
+            <a:ext cx="5667070" cy="313351"/>
           </a:xfrm>
           <a:prstGeom prst="rect">
             <a:avLst/>
@@ -3385,40 +3245,37 @@
           </a:extLst>
         </p:spPr>
         <p:txBody>
-          <a:bodyPr lIns="91423" tIns="91423" rIns="91423" bIns="91423" anchor="ctr">
+          <a:bodyPr lIns="45699" tIns="45699" rIns="45699" bIns="45699">
             <a:spAutoFit/>
           </a:bodyPr>
           <a:lstStyle>
             <a:lvl1pPr algn="ctr">
-              <a:lnSpc>
-                <a:spcPct val="115000"/>
-              </a:lnSpc>
-              <a:defRPr b="1" sz="2600">
-                <a:latin typeface="Avenir Next Regular"/>
-                <a:ea typeface="Avenir Next Regular"/>
-                <a:cs typeface="Avenir Next Regular"/>
-                <a:sym typeface="Avenir Next Regular"/>
+              <a:defRPr sz="1600">
+                <a:latin typeface="Arial"/>
+                <a:ea typeface="Arial"/>
+                <a:cs typeface="Arial"/>
+                <a:sym typeface="Arial"/>
               </a:defRPr>
             </a:lvl1pPr>
           </a:lstStyle>
           <a:p>
             <a:pPr/>
             <a:r>
-              <a:t>Job Type</a:t>
+              <a:t>Skills Required</a:t>
             </a:r>
           </a:p>
         </p:txBody>
       </p:sp>
       <p:sp>
         <p:nvSpPr>
-          <p:cNvPr id="120" name="Google Shape;66;p13"/>
+          <p:cNvPr id="115" name="Google Shape;77;p14"/>
           <p:cNvSpPr txBox="1"/>
           <p:nvPr/>
         </p:nvSpPr>
         <p:spPr>
           <a:xfrm>
-            <a:off x="468650" y="12906779"/>
-            <a:ext cx="7292400" cy="601949"/>
+            <a:off x="6215512" y="3710132"/>
+            <a:ext cx="5334003" cy="375189"/>
           </a:xfrm>
           <a:prstGeom prst="rect">
             <a:avLst/>
@@ -3433,40 +3290,37 @@
           </a:extLst>
         </p:spPr>
         <p:txBody>
-          <a:bodyPr lIns="91423" tIns="91423" rIns="91423" bIns="91423" anchor="ctr">
+          <a:bodyPr lIns="45699" tIns="45699" rIns="45699" bIns="45699">
             <a:spAutoFit/>
           </a:bodyPr>
           <a:lstStyle>
             <a:lvl1pPr algn="ctr">
-              <a:lnSpc>
-                <a:spcPct val="115000"/>
-              </a:lnSpc>
-              <a:defRPr sz="2400">
-                <a:latin typeface="Avenir Next Regular"/>
-                <a:ea typeface="Avenir Next Regular"/>
-                <a:cs typeface="Avenir Next Regular"/>
-                <a:sym typeface="Avenir Next Regular"/>
+              <a:defRPr sz="2000">
+                <a:latin typeface="Arial"/>
+                <a:ea typeface="Arial"/>
+                <a:cs typeface="Arial"/>
+                <a:sym typeface="Arial"/>
               </a:defRPr>
             </a:lvl1pPr>
           </a:lstStyle>
           <a:p>
             <a:pPr/>
             <a:r>
-              <a:t>{{JOB_TYPE}}</a:t>
+              <a:t>{{SKILLS}}</a:t>
             </a:r>
           </a:p>
         </p:txBody>
       </p:sp>
       <p:sp>
         <p:nvSpPr>
-          <p:cNvPr id="121" name="{{COMPANY_NAME}}"/>
+          <p:cNvPr id="116" name="Google Shape;78;p14"/>
           <p:cNvSpPr txBox="1"/>
           <p:nvPr/>
         </p:nvSpPr>
         <p:spPr>
           <a:xfrm>
-            <a:off x="265804" y="2686411"/>
-            <a:ext cx="7697993" cy="660401"/>
+            <a:off x="767236" y="4763375"/>
+            <a:ext cx="5084504" cy="313351"/>
           </a:xfrm>
           <a:prstGeom prst="rect">
             <a:avLst/>
@@ -3481,23 +3335,68 @@
           </a:extLst>
         </p:spPr>
         <p:txBody>
-          <a:bodyPr lIns="0" tIns="0" rIns="0" bIns="0">
+          <a:bodyPr lIns="45699" tIns="45699" rIns="45699" bIns="45699">
             <a:spAutoFit/>
           </a:bodyPr>
           <a:lstStyle>
             <a:lvl1pPr algn="ctr">
-              <a:defRPr b="1" sz="3800">
-                <a:latin typeface="Avenir Next Regular"/>
-                <a:ea typeface="Avenir Next Regular"/>
-                <a:cs typeface="Avenir Next Regular"/>
-                <a:sym typeface="Avenir Next Regular"/>
+              <a:defRPr sz="1600">
+                <a:latin typeface="Arial"/>
+                <a:ea typeface="Arial"/>
+                <a:cs typeface="Arial"/>
+                <a:sym typeface="Arial"/>
               </a:defRPr>
             </a:lvl1pPr>
           </a:lstStyle>
           <a:p>
             <a:pPr/>
             <a:r>
-              <a:t>{{COMPANY_NAME}}</a:t>
+              <a:t>Location</a:t>
+            </a:r>
+          </a:p>
+        </p:txBody>
+      </p:sp>
+      <p:sp>
+        <p:nvSpPr>
+          <p:cNvPr id="117" name="Google Shape;79;p14"/>
+          <p:cNvSpPr txBox="1"/>
+          <p:nvPr/>
+        </p:nvSpPr>
+        <p:spPr>
+          <a:xfrm>
+            <a:off x="642485" y="5072745"/>
+            <a:ext cx="5334005" cy="375189"/>
+          </a:xfrm>
+          <a:prstGeom prst="rect">
+            <a:avLst/>
+          </a:prstGeom>
+          <a:ln w="12700">
+            <a:miter lim="400000"/>
+          </a:ln>
+          <a:extLst>
+            <a:ext uri="{C572A759-6A51-4108-AA02-DFA0A04FC94B}">
+              <ma14:wrappingTextBoxFlag xmlns:ma14="http://schemas.microsoft.com/office/mac/drawingml/2011/main" val="1"/>
+            </a:ext>
+          </a:extLst>
+        </p:spPr>
+        <p:txBody>
+          <a:bodyPr lIns="45699" tIns="45699" rIns="45699" bIns="45699">
+            <a:spAutoFit/>
+          </a:bodyPr>
+          <a:lstStyle>
+            <a:lvl1pPr algn="ctr">
+              <a:defRPr sz="2000">
+                <a:latin typeface="Arial"/>
+                <a:ea typeface="Arial"/>
+                <a:cs typeface="Arial"/>
+                <a:sym typeface="Arial"/>
+              </a:defRPr>
+            </a:lvl1pPr>
+          </a:lstStyle>
+          <a:p>
+            <a:pPr/>
+            <a:r>
+              <a:t>{{LOCATION}}</a:t>
             </a:r>
           </a:p>
         </p:txBody>
@@ -3512,9 +3411,9 @@
 </file>
 
 <file path=ppt/theme/theme1.xml><?xml version="1.0" encoding="utf-8"?>
-<a:theme xmlns:a="http://schemas.openxmlformats.org/drawingml/2006/main" xmlns:r="http://schemas.openxmlformats.org/officeDocument/2006/relationships" name="Simple Light">
+<a:theme xmlns:a="http://schemas.openxmlformats.org/drawingml/2006/main" xmlns:r="http://schemas.openxmlformats.org/officeDocument/2006/relationships" name="Office Theme">
   <a:themeElements>
-    <a:clrScheme name="Simple Light">
+    <a:clrScheme name="Office Theme">
       <a:dk1>
         <a:srgbClr val="000000"/>
       </a:dk1>
@@ -3528,22 +3427,22 @@
         <a:srgbClr val="535353"/>
       </a:lt2>
       <a:accent1>
-        <a:srgbClr val="4285F4"/>
+        <a:srgbClr val="156082"/>
       </a:accent1>
       <a:accent2>
-        <a:srgbClr val="212121"/>
+        <a:srgbClr val="E97132"/>
       </a:accent2>
       <a:accent3>
-        <a:srgbClr val="78909C"/>
+        <a:srgbClr val="196B24"/>
       </a:accent3>
       <a:accent4>
-        <a:srgbClr val="FFAB40"/>
+        <a:srgbClr val="0F9ED5"/>
       </a:accent4>
       <a:accent5>
-        <a:srgbClr val="0097A7"/>
+        <a:srgbClr val="A02B93"/>
       </a:accent5>
       <a:accent6>
-        <a:srgbClr val="EEFF41"/>
+        <a:srgbClr val="4EA72E"/>
       </a:accent6>
       <a:hlink>
         <a:srgbClr val="0000FF"/>
@@ -3552,19 +3451,19 @@
         <a:srgbClr val="FF00FF"/>
       </a:folHlink>
     </a:clrScheme>
-    <a:fontScheme name="Simple Light">
+    <a:fontScheme name="Office Theme">
       <a:majorFont>
+        <a:latin typeface="Aptos"/>
+        <a:ea typeface="Aptos"/>
+        <a:cs typeface="Aptos"/>
+      </a:majorFont>
+      <a:minorFont>
         <a:latin typeface="Helvetica"/>
         <a:ea typeface="Helvetica"/>
         <a:cs typeface="Helvetica"/>
-      </a:majorFont>
-      <a:minorFont>
-        <a:latin typeface="Arial"/>
-        <a:ea typeface="Arial"/>
-        <a:cs typeface="Arial"/>
       </a:minorFont>
     </a:fontScheme>
-    <a:fmtScheme name="Simple Light">
+    <a:fmtScheme name="Office Theme">
       <a:fillStyleLst>
         <a:solidFill>
           <a:schemeClr val="phClr"/>
@@ -3714,7 +3613,7 @@
         <a:effectLst/>
         <a:sp3d/>
       </a:spPr>
-      <a:bodyPr rot="0" spcFirstLastPara="1" vertOverflow="overflow" horzOverflow="overflow" vert="horz" wrap="square" lIns="0" tIns="0" rIns="0" bIns="0" numCol="1" spcCol="38100" rtlCol="0" anchor="t" upright="0">
+      <a:bodyPr rot="0" spcFirstLastPara="1" vertOverflow="overflow" horzOverflow="overflow" vert="horz" wrap="square" lIns="45718" tIns="45718" rIns="45718" bIns="45718" numCol="1" spcCol="38100" rtlCol="0" anchor="ctr" upright="0">
         <a:spAutoFit/>
       </a:bodyPr>
       <a:lstStyle>
@@ -3733,7 +3632,7 @@
           <a:buFontTx/>
           <a:buNone/>
           <a:tabLst/>
-          <a:defRPr b="0" baseline="0" cap="none" i="0" spc="0" strike="noStrike" sz="1400" u="none" kumimoji="0" normalizeH="0">
+          <a:defRPr b="0" baseline="0" cap="none" i="0" spc="0" strike="noStrike" sz="1800" u="none" kumimoji="0" normalizeH="0">
             <a:ln>
               <a:noFill/>
             </a:ln>
@@ -3745,7 +3644,7 @@
             <a:latin typeface="+mn-lt"/>
             <a:ea typeface="+mn-ea"/>
             <a:cs typeface="+mn-cs"/>
-            <a:sym typeface="Arial"/>
+            <a:sym typeface="Helvetica"/>
           </a:defRPr>
         </a:defPPr>
         <a:lvl1pPr marL="0" marR="0" indent="0" algn="l" defTabSz="914400" rtl="0" fontAlgn="auto" latinLnBrk="1" hangingPunct="0">
@@ -4285,7 +4184,7 @@
         <a:effectLst/>
         <a:sp3d/>
       </a:spPr>
-      <a:bodyPr rot="0" spcFirstLastPara="1" vertOverflow="overflow" horzOverflow="overflow" vert="horz" wrap="square" lIns="0" tIns="0" rIns="0" bIns="0" numCol="1" spcCol="38100" rtlCol="0" anchor="t" upright="0">
+      <a:bodyPr rot="0" spcFirstLastPara="1" vertOverflow="overflow" horzOverflow="overflow" vert="horz" wrap="square" lIns="45718" tIns="45718" rIns="45718" bIns="45718" numCol="1" spcCol="38100" rtlCol="0" anchor="t" upright="0">
         <a:spAutoFit/>
       </a:bodyPr>
       <a:lstStyle>
@@ -4304,7 +4203,7 @@
           <a:buFontTx/>
           <a:buNone/>
           <a:tabLst/>
-          <a:defRPr b="0" baseline="0" cap="none" i="0" spc="0" strike="noStrike" sz="1400" u="none" kumimoji="0" normalizeH="0">
+          <a:defRPr b="0" baseline="0" cap="none" i="0" spc="0" strike="noStrike" sz="1800" u="none" kumimoji="0" normalizeH="0">
             <a:ln>
               <a:noFill/>
             </a:ln>
@@ -4316,7 +4215,7 @@
             <a:latin typeface="+mn-lt"/>
             <a:ea typeface="+mn-ea"/>
             <a:cs typeface="+mn-cs"/>
-            <a:sym typeface="Arial"/>
+            <a:sym typeface="Helvetica"/>
           </a:defRPr>
         </a:defPPr>
         <a:lvl1pPr marL="0" marR="0" indent="0" algn="l" defTabSz="914400" rtl="0" fontAlgn="auto" latinLnBrk="1" hangingPunct="0">
@@ -4566,9 +4465,9 @@
 </file>
 
 <file path=ppt/theme/theme2.xml><?xml version="1.0" encoding="utf-8"?>
-<a:theme xmlns:a="http://schemas.openxmlformats.org/drawingml/2006/main" xmlns:r="http://schemas.openxmlformats.org/officeDocument/2006/relationships" name="Simple Light">
+<a:theme xmlns:a="http://schemas.openxmlformats.org/drawingml/2006/main" xmlns:r="http://schemas.openxmlformats.org/officeDocument/2006/relationships" name="Office Theme">
   <a:themeElements>
-    <a:clrScheme name="Simple Light">
+    <a:clrScheme name="Office Theme">
       <a:dk1>
         <a:srgbClr val="000000"/>
       </a:dk1>
@@ -4582,22 +4481,22 @@
         <a:srgbClr val="535353"/>
       </a:lt2>
       <a:accent1>
-        <a:srgbClr val="4285F4"/>
+        <a:srgbClr val="156082"/>
       </a:accent1>
       <a:accent2>
-        <a:srgbClr val="212121"/>
+        <a:srgbClr val="E97132"/>
       </a:accent2>
       <a:accent3>
-        <a:srgbClr val="78909C"/>
+        <a:srgbClr val="196B24"/>
       </a:accent3>
       <a:accent4>
-        <a:srgbClr val="FFAB40"/>
+        <a:srgbClr val="0F9ED5"/>
       </a:accent4>
       <a:accent5>
-        <a:srgbClr val="0097A7"/>
+        <a:srgbClr val="A02B93"/>
       </a:accent5>
       <a:accent6>
-        <a:srgbClr val="EEFF41"/>
+        <a:srgbClr val="4EA72E"/>
       </a:accent6>
       <a:hlink>
         <a:srgbClr val="0000FF"/>
@@ -4606,19 +4505,19 @@
         <a:srgbClr val="FF00FF"/>
       </a:folHlink>
     </a:clrScheme>
-    <a:fontScheme name="Simple Light">
+    <a:fontScheme name="Office Theme">
       <a:majorFont>
+        <a:latin typeface="Aptos"/>
+        <a:ea typeface="Aptos"/>
+        <a:cs typeface="Aptos"/>
+      </a:majorFont>
+      <a:minorFont>
         <a:latin typeface="Helvetica"/>
         <a:ea typeface="Helvetica"/>
         <a:cs typeface="Helvetica"/>
-      </a:majorFont>
-      <a:minorFont>
-        <a:latin typeface="Arial"/>
-        <a:ea typeface="Arial"/>
-        <a:cs typeface="Arial"/>
       </a:minorFont>
     </a:fontScheme>
-    <a:fmtScheme name="Simple Light">
+    <a:fmtScheme name="Office Theme">
       <a:fillStyleLst>
         <a:solidFill>
           <a:schemeClr val="phClr"/>
@@ -4768,7 +4667,7 @@
         <a:effectLst/>
         <a:sp3d/>
       </a:spPr>
-      <a:bodyPr rot="0" spcFirstLastPara="1" vertOverflow="overflow" horzOverflow="overflow" vert="horz" wrap="square" lIns="0" tIns="0" rIns="0" bIns="0" numCol="1" spcCol="38100" rtlCol="0" anchor="t" upright="0">
+      <a:bodyPr rot="0" spcFirstLastPara="1" vertOverflow="overflow" horzOverflow="overflow" vert="horz" wrap="square" lIns="45718" tIns="45718" rIns="45718" bIns="45718" numCol="1" spcCol="38100" rtlCol="0" anchor="ctr" upright="0">
         <a:spAutoFit/>
       </a:bodyPr>
       <a:lstStyle>
@@ -4787,7 +4686,7 @@
           <a:buFontTx/>
           <a:buNone/>
           <a:tabLst/>
-          <a:defRPr b="0" baseline="0" cap="none" i="0" spc="0" strike="noStrike" sz="1400" u="none" kumimoji="0" normalizeH="0">
+          <a:defRPr b="0" baseline="0" cap="none" i="0" spc="0" strike="noStrike" sz="1800" u="none" kumimoji="0" normalizeH="0">
             <a:ln>
               <a:noFill/>
             </a:ln>
@@ -4799,7 +4698,7 @@
             <a:latin typeface="+mn-lt"/>
             <a:ea typeface="+mn-ea"/>
             <a:cs typeface="+mn-cs"/>
-            <a:sym typeface="Arial"/>
+            <a:sym typeface="Helvetica"/>
           </a:defRPr>
         </a:defPPr>
         <a:lvl1pPr marL="0" marR="0" indent="0" algn="l" defTabSz="914400" rtl="0" fontAlgn="auto" latinLnBrk="1" hangingPunct="0">
@@ -5339,7 +5238,7 @@
         <a:effectLst/>
         <a:sp3d/>
       </a:spPr>
-      <a:bodyPr rot="0" spcFirstLastPara="1" vertOverflow="overflow" horzOverflow="overflow" vert="horz" wrap="square" lIns="0" tIns="0" rIns="0" bIns="0" numCol="1" spcCol="38100" rtlCol="0" anchor="t" upright="0">
+      <a:bodyPr rot="0" spcFirstLastPara="1" vertOverflow="overflow" horzOverflow="overflow" vert="horz" wrap="square" lIns="45718" tIns="45718" rIns="45718" bIns="45718" numCol="1" spcCol="38100" rtlCol="0" anchor="t" upright="0">
         <a:spAutoFit/>
       </a:bodyPr>
       <a:lstStyle>
@@ -5358,7 +5257,7 @@
           <a:buFontTx/>
           <a:buNone/>
           <a:tabLst/>
-          <a:defRPr b="0" baseline="0" cap="none" i="0" spc="0" strike="noStrike" sz="1400" u="none" kumimoji="0" normalizeH="0">
+          <a:defRPr b="0" baseline="0" cap="none" i="0" spc="0" strike="noStrike" sz="1800" u="none" kumimoji="0" normalizeH="0">
             <a:ln>
               <a:noFill/>
             </a:ln>
@@ -5370,7 +5269,7 @@
             <a:latin typeface="+mn-lt"/>
             <a:ea typeface="+mn-ea"/>
             <a:cs typeface="+mn-cs"/>
-            <a:sym typeface="Arial"/>
+            <a:sym typeface="Helvetica"/>
           </a:defRPr>
         </a:defPPr>
         <a:lvl1pPr marL="0" marR="0" indent="0" algn="l" defTabSz="914400" rtl="0" fontAlgn="auto" latinLnBrk="1" hangingPunct="0">

</xml_diff>